<commit_message>
python programlamaya giriş dersi işlendi.
</commit_message>
<xml_diff>
--- a/hafta_3/Modelleme-problemin-turuyle-baslar.pptx
+++ b/hafta_3/Modelleme-problemin-turuyle-baslar.pptx
@@ -1,9 +1,12 @@
 
 <file path=ppt/presentation.xml><?xml version="1.0" encoding="utf-8"?>
-<p:presentation xmlns:a="http://schemas.openxmlformats.org/drawingml/2006/main" xmlns:r="http://schemas.openxmlformats.org/officeDocument/2006/relationships" xmlns:p="http://schemas.openxmlformats.org/presentationml/2006/main" saveSubsetFonts="true" autoCompressPictures="0" embedTrueTypeFonts="true">
+<p:presentation xmlns:a="http://schemas.openxmlformats.org/drawingml/2006/main" xmlns:r="http://schemas.openxmlformats.org/officeDocument/2006/relationships" xmlns:p="http://schemas.openxmlformats.org/presentationml/2006/main" embedTrueTypeFonts="1" saveSubsetFonts="1" autoCompressPictures="0">
   <p:sldMasterIdLst>
     <p:sldMasterId id="2147483648" r:id="rId1"/>
   </p:sldMasterIdLst>
+  <p:notesMasterIdLst>
+    <p:notesMasterId r:id="rId12"/>
+  </p:notesMasterIdLst>
   <p:sldIdLst>
     <p:sldId id="256" r:id="rId2"/>
     <p:sldId id="257" r:id="rId3"/>
@@ -16,27 +19,20 @@
     <p:sldId id="264" r:id="rId10"/>
     <p:sldId id="265" r:id="rId11"/>
   </p:sldIdLst>
-  <p:notesMasterIdLst>
-    <p:notesMasterId r:id="rId12"/>
-  </p:notesMasterIdLst>
-  <p:sldSz cx="12191695" cy="6858000"/>
-  <p:notesSz cx="6858000" cy="12191695"/>
+  <p:sldSz cx="12192000" cy="6858000"/>
+  <p:notesSz cx="6858000" cy="12192000"/>
   <p:embeddedFontLst>
     <p:embeddedFont>
       <p:font typeface="Encode Sans Semi Condensed SemiBold"/>
-      <p:regular r:id="rId201314"/>
+      <p:regular r:id="rId13"/>
     </p:embeddedFont>
     <p:embeddedFont>
-      <p:font typeface="Fira Sans"/>
-      <p:regular r:id="rId201315"/>
+      <p:font typeface="Fira Sans" panose="020B0503050000020004" pitchFamily="34" charset="0"/>
+      <p:regular r:id="rId14"/>
     </p:embeddedFont>
     <p:embeddedFont>
-      <p:font typeface="Fira Sans Bold"/>
-      <p:regular r:id="rId201316"/>
-    </p:embeddedFont>
-    <p:embeddedFont>
-      <p:font typeface="Overpass Mono Medium"/>
-      <p:regular r:id="rId201317"/>
+      <p:font typeface="Overpass Mono Medium" panose="020B0604020202020204" charset="-94"/>
+      <p:regular r:id="rId15"/>
     </p:embeddedFont>
   </p:embeddedFontLst>
   <p:defaultTextStyle>
@@ -131,6 +127,11 @@
       </a:defRPr>
     </a:lvl9pPr>
   </p:defaultTextStyle>
+  <p:extLst>
+    <p:ext uri="{EFAFB233-063F-42B5-8137-9DF3F51BA10A}">
+      <p15:sldGuideLst xmlns:p15="http://schemas.microsoft.com/office/powerpoint/2012/main"/>
+    </p:ext>
+  </p:extLst>
 </p:presentation>
 </file>
 
@@ -156,234 +157,10 @@
           <a:chExt cx="0" cy="0"/>
         </a:xfrm>
       </p:grpSpPr>
-      <p:sp>
-        <p:nvSpPr>
-          <p:cNvPr id="2" name="Header Placeholder 1"/>
-          <p:cNvSpPr>
-            <a:spLocks noGrp="1"/>
-          </p:cNvSpPr>
-          <p:nvPr>
-            <p:ph type="hdr" sz="quarter"/>
-          </p:nvPr>
-        </p:nvSpPr>
-        <p:spPr>
-          <a:xfrm>
-            <a:off x="0" y="0"/>
-            <a:ext cx="2971800" cy="458788"/>
-          </a:xfrm>
-          <a:prstGeom prst="rect">
-            <a:avLst/>
-          </a:prstGeom>
-        </p:spPr>
-        <p:txBody>
-          <a:bodyPr vert="horz" lIns="91440" tIns="45720" rIns="91440" bIns="45720" rtlCol="0"/>
-          <a:lstStyle>
-            <a:lvl1pPr algn="l">
-              <a:defRPr sz="1200"/>
-            </a:lvl1pPr>
-          </a:lstStyle>
-          <a:p>
-            <a:endParaRPr lang="en-US"/>
-          </a:p>
-        </p:txBody>
-      </p:sp>
-      <p:sp>
-        <p:nvSpPr>
-          <p:cNvPr id="3" name="Date Placeholder 2"/>
-          <p:cNvSpPr>
-            <a:spLocks noGrp="1"/>
-          </p:cNvSpPr>
-          <p:nvPr>
-            <p:ph type="dt" idx="1"/>
-          </p:nvPr>
-        </p:nvSpPr>
-        <p:spPr>
-          <a:xfrm>
-            <a:off x="3884613" y="0"/>
-            <a:ext cx="2971800" cy="458788"/>
-          </a:xfrm>
-          <a:prstGeom prst="rect">
-            <a:avLst/>
-          </a:prstGeom>
-        </p:spPr>
-        <p:txBody>
-          <a:bodyPr vert="horz" lIns="91440" tIns="45720" rIns="91440" bIns="45720" rtlCol="0"/>
-          <a:lstStyle>
-            <a:lvl1pPr algn="r">
-              <a:defRPr sz="1200"/>
-            </a:lvl1pPr>
-          </a:lstStyle>
-          <a:p>
-            <a:fld id="{5282F153-3F37-0F45-9E97-73ACFA13230C}" type="datetimeFigureOut">
-              <a:rPr lang="en-US"/>
-              <a:t>7/23/19</a:t>
-            </a:fld>
-            <a:endParaRPr lang="en-US"/>
-          </a:p>
-        </p:txBody>
-      </p:sp>
-      <p:sp>
-        <p:nvSpPr>
-          <p:cNvPr id="4" name="Slide Image Placeholder 3"/>
-          <p:cNvSpPr>
-            <a:spLocks noGrp="1" noRot="1" noChangeAspect="1"/>
-          </p:cNvSpPr>
-          <p:nvPr>
-            <p:ph type="sldImg" idx="2"/>
-          </p:nvPr>
-        </p:nvSpPr>
-        <p:spPr>
-          <a:xfrm>
-            <a:off x="685800" y="1143000"/>
-            <a:ext cx="5486400" cy="3086100"/>
-          </a:xfrm>
-          <a:prstGeom prst="rect">
-            <a:avLst/>
-          </a:prstGeom>
-          <a:noFill/>
-          <a:ln w="12700">
-            <a:solidFill>
-              <a:prstClr val="black"/>
-            </a:solidFill>
-          </a:ln>
-        </p:spPr>
-        <p:txBody>
-          <a:bodyPr vert="horz" lIns="91440" tIns="45720" rIns="91440" bIns="45720" rtlCol="0" anchor="ctr"/>
-          <a:lstStyle/>
-          <a:p>
-            <a:endParaRPr lang="en-US"/>
-          </a:p>
-        </p:txBody>
-      </p:sp>
-      <p:sp>
-        <p:nvSpPr>
-          <p:cNvPr id="5" name="Notes Placeholder 4"/>
-          <p:cNvSpPr>
-            <a:spLocks noGrp="1"/>
-          </p:cNvSpPr>
-          <p:nvPr>
-            <p:ph type="body" sz="quarter" idx="3"/>
-          </p:nvPr>
-        </p:nvSpPr>
-        <p:spPr>
-          <a:xfrm>
-            <a:off x="685800" y="4400550"/>
-            <a:ext cx="5486400" cy="3600450"/>
-          </a:xfrm>
-          <a:prstGeom prst="rect">
-            <a:avLst/>
-          </a:prstGeom>
-        </p:spPr>
-        <p:txBody>
-          <a:bodyPr vert="horz" lIns="91440" tIns="45720" rIns="91440" bIns="45720" rtlCol="0"/>
-          <a:lstStyle/>
-          <a:p>
-            <a:pPr lvl="0"/>
-            <a:r>
-              <a:rPr lang="en-US"/>
-              <a:t>Click to edit Master text styles</a:t>
-            </a:r>
-          </a:p>
-          <a:p>
-            <a:pPr lvl="1"/>
-            <a:r>
-              <a:rPr lang="en-US"/>
-              <a:t>Second level</a:t>
-            </a:r>
-          </a:p>
-          <a:p>
-            <a:pPr lvl="2"/>
-            <a:r>
-              <a:rPr lang="en-US"/>
-              <a:t>Third level</a:t>
-            </a:r>
-          </a:p>
-          <a:p>
-            <a:pPr lvl="3"/>
-            <a:r>
-              <a:rPr lang="en-US"/>
-              <a:t>Fourth level</a:t>
-            </a:r>
-          </a:p>
-          <a:p>
-            <a:pPr lvl="4"/>
-            <a:r>
-              <a:rPr lang="en-US"/>
-              <a:t>Fifth level</a:t>
-            </a:r>
-          </a:p>
-        </p:txBody>
-      </p:sp>
-      <p:sp>
-        <p:nvSpPr>
-          <p:cNvPr id="6" name="Footer Placeholder 5"/>
-          <p:cNvSpPr>
-            <a:spLocks noGrp="1"/>
-          </p:cNvSpPr>
-          <p:nvPr>
-            <p:ph type="ftr" sz="quarter" idx="4"/>
-          </p:nvPr>
-        </p:nvSpPr>
-        <p:spPr>
-          <a:xfrm>
-            <a:off x="0" y="8685213"/>
-            <a:ext cx="2971800" cy="458787"/>
-          </a:xfrm>
-          <a:prstGeom prst="rect">
-            <a:avLst/>
-          </a:prstGeom>
-        </p:spPr>
-        <p:txBody>
-          <a:bodyPr vert="horz" lIns="91440" tIns="45720" rIns="91440" bIns="45720" rtlCol="0" anchor="b"/>
-          <a:lstStyle>
-            <a:lvl1pPr algn="l">
-              <a:defRPr sz="1200"/>
-            </a:lvl1pPr>
-          </a:lstStyle>
-          <a:p>
-            <a:endParaRPr lang="en-US"/>
-          </a:p>
-        </p:txBody>
-      </p:sp>
-      <p:sp>
-        <p:nvSpPr>
-          <p:cNvPr id="7" name="Slide Number Placeholder 6"/>
-          <p:cNvSpPr>
-            <a:spLocks noGrp="1"/>
-          </p:cNvSpPr>
-          <p:nvPr>
-            <p:ph type="sldNum" sz="quarter" idx="5"/>
-          </p:nvPr>
-        </p:nvSpPr>
-        <p:spPr>
-          <a:xfrm>
-            <a:off x="3884613" y="8685213"/>
-            <a:ext cx="2971800" cy="458787"/>
-          </a:xfrm>
-          <a:prstGeom prst="rect">
-            <a:avLst/>
-          </a:prstGeom>
-        </p:spPr>
-        <p:txBody>
-          <a:bodyPr vert="horz" lIns="91440" tIns="45720" rIns="91440" bIns="45720" rtlCol="0" anchor="b"/>
-          <a:lstStyle>
-            <a:lvl1pPr algn="r">
-              <a:defRPr sz="1200"/>
-            </a:lvl1pPr>
-          </a:lstStyle>
-          <a:p>
-            <a:fld id="{CE5E9CC1-C706-0F49-92D6-E571CC5EEA8F}" type="slidenum">
-              <a:rPr lang="en-US"/>
-              <a:t>‹#›</a:t>
-            </a:fld>
-            <a:endParaRPr lang="en-US"/>
-          </a:p>
-        </p:txBody>
-      </p:sp>
     </p:spTree>
     <p:extLst>
       <p:ext uri="{BB962C8B-B14F-4D97-AF65-F5344CB8AC3E}">
-        <p14:creationId xmlns:p14="http://schemas.microsoft.com/office/powerpoint/2010/main" val="1024086991"/>
+        <p14:creationId xmlns:p14="http://schemas.microsoft.com/office/powerpoint/2010/main" val="3633258363"/>
       </p:ext>
     </p:extLst>
   </p:cSld>
@@ -531,7 +308,6 @@
               <a:rPr lang="en-US" dirty="0"/>
               <a:t>Açılışta şunu vurgulayın: algoritma seçimi, problemin türü netleşmeden anlamlı değildir. Bu derste önce problem ailelerini, sonra her birinin yaklaşımlarını ve zorluklarını ele alacağız.</a:t>
             </a:r>
-            <a:endParaRPr lang="en-US" dirty="0"/>
           </a:p>
         </p:txBody>
       </p:sp>
@@ -619,7 +395,6 @@
               <a:rPr lang="en-US" dirty="0"/>
               <a:t>Kümelerin tek bir doğru cevabı olmayabilir. Bu yüzden her keşfi bir iş kararına bağlayın ve sonucu ekibe gösterin.</a:t>
             </a:r>
-            <a:endParaRPr lang="en-US" dirty="0"/>
           </a:p>
         </p:txBody>
       </p:sp>
@@ -707,7 +482,6 @@
               <a:rPr lang="en-US" dirty="0"/>
               <a:t>Soruları yukarıdan aşağıya sorun: hedef etiketli mi, çıktı kategorik mi, sıralı karar ve ödül var mı. Aynı veri bu üç yanıtla farklı bir problem olur.</a:t>
             </a:r>
-            <a:endParaRPr lang="en-US" dirty="0"/>
           </a:p>
         </p:txBody>
       </p:sp>
@@ -795,7 +569,6 @@
               <a:rPr lang="en-US" dirty="0"/>
               <a:t>Noktalar iki sınıfı temsil ediyor. Model, bu iki bölgeyi ayıran sınırı öğrenir ve sınırın yeni noktaları doğru tarafa koymasını bekler.</a:t>
             </a:r>
-            <a:endParaRPr lang="en-US" dirty="0"/>
           </a:p>
         </p:txBody>
       </p:sp>
@@ -883,7 +656,6 @@
               <a:rPr lang="en-US" dirty="0"/>
               <a:t>Yaklaşımı veri türü belirler. Tablolarda ağaç tabanlı modeller hâlâ çok güçlü bir başlangıçtır. Accuracy tek başına yanıltabilir, bu yüzden birlikte izleyin.</a:t>
             </a:r>
-            <a:endParaRPr lang="en-US" dirty="0"/>
           </a:p>
         </p:txBody>
       </p:sp>
@@ -971,7 +743,6 @@
               <a:rPr lang="en-US" dirty="0"/>
               <a:t>Her satır aynı soruyu sorar: bu karar kategorik mi? Finans ve siber güvenlikte karar çoğu zaman saniyeler içinde verilir.</a:t>
             </a:r>
-            <a:endParaRPr lang="en-US" dirty="0"/>
           </a:p>
         </p:txBody>
       </p:sp>
@@ -1059,7 +830,6 @@
               <a:rPr lang="en-US" dirty="0"/>
               <a:t>Turuncu çizgi tahmini, bant ise belirsizliği gösterir. Karar verirken bant kadar çizginin kendisi de önemlidir.</a:t>
             </a:r>
-            <a:endParaRPr lang="en-US" dirty="0"/>
           </a:p>
         </p:txBody>
       </p:sp>
@@ -1147,7 +917,6 @@
               <a:rPr lang="en-US" dirty="0"/>
               <a:t>Doğrusal model her zaman ilk adımdır. Karmaşık modele geçmeden önce neyi neden kaçırdığını görün. Metrik seçimi de iş kararına bağlıdır.</a:t>
             </a:r>
-            <a:endParaRPr lang="en-US" dirty="0"/>
           </a:p>
         </p:txBody>
       </p:sp>
@@ -1235,7 +1004,6 @@
               <a:rPr lang="en-US" dirty="0"/>
               <a:t>Her sektörde tahmin, bir kaynak kararına bağlanır: stok, vardiya, bakım ya da teslimat penceresi. Bu yüzden aralığı da gösterin.</a:t>
             </a:r>
-            <a:endParaRPr lang="en-US" dirty="0"/>
           </a:p>
         </p:txBody>
       </p:sp>
@@ -1323,7 +1091,6 @@
               <a:rPr lang="en-US" dirty="0"/>
               <a:t>Renkler otomatik etiket değildir. Yeşil gruplar modelin bulduğu kümelerdir, kesikli sınırlar ise tartışmalı bölgeleri gösterir. Turuncu nokta bir anomalidir.</a:t>
             </a:r>
-            <a:endParaRPr lang="en-US" dirty="0"/>
           </a:p>
         </p:txBody>
       </p:sp>
@@ -1401,6 +1168,7 @@
         <a:solidFill>
           <a:srgbClr val="051230"/>
         </a:solidFill>
+        <a:effectLst/>
       </p:bgPr>
     </p:bg>
     <p:spTree>
@@ -1419,14 +1187,14 @@
       </p:grpSpPr>
       <p:pic>
         <p:nvPicPr>
-          <p:cNvPr id="2" name="Image 0" descr="preencoded.png">    </p:cNvPr>
+          <p:cNvPr id="2" name="Image 0" descr="preencoded.png"/>
           <p:cNvPicPr>
             <a:picLocks noChangeAspect="1"/>
           </p:cNvPicPr>
           <p:nvPr/>
         </p:nvPicPr>
         <p:blipFill>
-          <a:blip r:embed="rId1"/>
+          <a:blip r:embed="rId2"/>
           <a:stretch>
             <a:fillRect/>
           </a:stretch>
@@ -1444,7 +1212,7 @@
       <p:pic>
         <p:nvPicPr>
           <p:cNvPr id="3" name="Image 1" descr="preencoded.png">
-            <a:hlinkClick r:id="rId3" tooltip=""/>
+            <a:hlinkClick r:id="rId3"/>
           </p:cNvPr>
           <p:cNvPicPr>
             <a:picLocks noChangeAspect="1"/>
@@ -1452,7 +1220,7 @@
           <p:nvPr/>
         </p:nvPicPr>
         <p:blipFill>
-          <a:blip r:embed="rId2"/>
+          <a:blip r:embed="rId4"/>
           <a:stretch>
             <a:fillRect/>
           </a:stretch>
@@ -1483,6 +1251,7 @@
         <a:solidFill>
           <a:srgbClr val="051230"/>
         </a:solidFill>
+        <a:effectLst/>
       </p:bgPr>
     </p:bg>
     <p:spTree>
@@ -1502,7 +1271,7 @@
       <p:pic>
         <p:nvPicPr>
           <p:cNvPr id="2" name="Image 0" descr="preencoded.png">
-            <a:hlinkClick r:id="rId2" tooltip=""/>
+            <a:hlinkClick r:id="rId2"/>
           </p:cNvPr>
           <p:cNvPicPr>
             <a:picLocks noChangeAspect="1"/>
@@ -1510,7 +1279,7 @@
           <p:nvPr/>
         </p:nvPicPr>
         <p:blipFill>
-          <a:blip r:embed="rId1"/>
+          <a:blip r:embed="rId3"/>
           <a:stretch>
             <a:fillRect/>
           </a:stretch>
@@ -1536,6 +1305,11 @@
 <file path=ppt/slideMasters/slideMaster1.xml><?xml version="1.0" encoding="utf-8"?>
 <p:sldMaster xmlns:a="http://schemas.openxmlformats.org/drawingml/2006/main" xmlns:r="http://schemas.openxmlformats.org/officeDocument/2006/relationships" xmlns:p="http://schemas.openxmlformats.org/presentationml/2006/main">
   <p:cSld>
+    <p:bg>
+      <p:bgRef idx="1001">
+        <a:schemeClr val="bg1"/>
+      </p:bgRef>
+    </p:bg>
     <p:spTree>
       <p:nvGrpSpPr>
         <p:cNvPr id="1" name=""/>
@@ -1837,7 +1611,7 @@
         </p:nvSpPr>
         <p:spPr>
           <a:xfrm>
-            <a:off x="812780" y="1905000"/>
+            <a:off x="569499" y="931877"/>
             <a:ext cx="7467413" cy="190500"/>
           </a:xfrm>
           <a:prstGeom prst="rect">
@@ -1850,14 +1624,14 @@
           <a:bodyPr wrap="none" lIns="0" tIns="0" rIns="0" bIns="0" rtlCol="0" anchor="t"/>
           <a:lstStyle/>
           <a:p>
-            <a:pPr algn="l" indent="0" marL="0">
+            <a:pPr marL="0" indent="0" algn="l">
               <a:lnSpc>
                 <a:spcPct val="104000"/>
               </a:lnSpc>
               <a:buNone/>
             </a:pPr>
             <a:r>
-              <a:rPr lang="en-US" sz="1200" spc="72" kern="100" dirty="0">
+              <a:rPr lang="en-US" sz="1200" kern="100" spc="72" dirty="0">
                 <a:solidFill>
                   <a:srgbClr val="FFFFFF"/>
                 </a:solidFill>
@@ -1879,7 +1653,7 @@
         </p:nvSpPr>
         <p:spPr>
           <a:xfrm>
-            <a:off x="812780" y="2253996"/>
+            <a:off x="569499" y="1280873"/>
             <a:ext cx="6857828" cy="1398984"/>
           </a:xfrm>
           <a:prstGeom prst="rect">
@@ -1890,18 +1664,18 @@
         </p:spPr>
         <p:txBody>
           <a:bodyPr wrap="square" lIns="0" tIns="0" rIns="0" bIns="0" rtlCol="0" anchor="t">
-            <a:normAutofit/>
+            <a:normAutofit fontScale="92500"/>
           </a:bodyPr>
           <a:lstStyle/>
           <a:p>
-            <a:pPr algn="l" indent="0" marL="0">
+            <a:pPr marL="0" indent="0" algn="l">
               <a:lnSpc>
                 <a:spcPct val="85000"/>
               </a:lnSpc>
               <a:buNone/>
             </a:pPr>
             <a:r>
-              <a:rPr lang="en-US" sz="5400" spc="-54" kern="100" dirty="0">
+              <a:rPr lang="en-US" sz="5400" kern="100" spc="-54" dirty="0">
                 <a:solidFill>
                   <a:srgbClr val="FFFFFF"/>
                 </a:solidFill>
@@ -1938,7 +1712,7 @@
           </a:bodyPr>
           <a:lstStyle/>
           <a:p>
-            <a:pPr algn="l" indent="0" marL="0">
+            <a:pPr marL="0" indent="0" algn="l">
               <a:lnSpc>
                 <a:spcPct val="118000"/>
               </a:lnSpc>
@@ -2005,14 +1779,14 @@
           <a:bodyPr wrap="none" lIns="0" tIns="0" rIns="0" bIns="0" rtlCol="0" anchor="t"/>
           <a:lstStyle/>
           <a:p>
-            <a:pPr algn="l" indent="0" marL="0">
+            <a:pPr marL="0" indent="0" algn="l">
               <a:lnSpc>
                 <a:spcPct val="104000"/>
               </a:lnSpc>
               <a:buNone/>
             </a:pPr>
             <a:r>
-              <a:rPr lang="en-US" sz="1200" spc="72" kern="100" dirty="0">
+              <a:rPr lang="en-US" sz="1200" kern="100" spc="72" dirty="0">
                 <a:solidFill>
                   <a:srgbClr val="00978D"/>
                 </a:solidFill>
@@ -2047,14 +1821,14 @@
           <a:bodyPr wrap="none" lIns="0" tIns="0" rIns="0" bIns="0" rtlCol="0" anchor="t"/>
           <a:lstStyle/>
           <a:p>
-            <a:pPr algn="l" indent="0" marL="0">
+            <a:pPr marL="0" indent="0" algn="l">
               <a:lnSpc>
                 <a:spcPct val="88000"/>
               </a:lnSpc>
               <a:buNone/>
             </a:pPr>
             <a:r>
-              <a:rPr lang="en-US" sz="3000" spc="-30" kern="100" dirty="0">
+              <a:rPr lang="en-US" sz="3000" kern="100" spc="-30" dirty="0">
                 <a:solidFill>
                   <a:srgbClr val="FFFFFF"/>
                 </a:solidFill>
@@ -2070,14 +1844,14 @@
       </p:sp>
       <p:pic>
         <p:nvPicPr>
-          <p:cNvPr id="4" name="Image 0" descr="preencoded.png">    </p:cNvPr>
+          <p:cNvPr id="4" name="Image 0" descr="preencoded.png"/>
           <p:cNvPicPr>
             <a:picLocks noChangeAspect="1"/>
           </p:cNvPicPr>
           <p:nvPr/>
         </p:nvPicPr>
         <p:blipFill>
-          <a:blip r:embed="rId1"/>
+          <a:blip r:embed="rId3"/>
           <a:stretch>
             <a:fillRect/>
           </a:stretch>
@@ -2115,7 +1889,7 @@
           </a:bodyPr>
           <a:lstStyle/>
           <a:p>
-            <a:pPr algn="l" marL="335280" indent="-335280">
+            <a:pPr marL="335280" indent="-335280" algn="l">
               <a:lnSpc>
                 <a:spcPct val="118000"/>
               </a:lnSpc>
@@ -2136,7 +1910,7 @@
             <a:endParaRPr lang="en-US" sz="1650" dirty="0"/>
           </a:p>
           <a:p>
-            <a:pPr algn="l" marL="335280" indent="-335280">
+            <a:pPr marL="335280" indent="-335280" algn="l">
               <a:lnSpc>
                 <a:spcPct val="118000"/>
               </a:lnSpc>
@@ -2157,7 +1931,7 @@
             <a:endParaRPr lang="en-US" sz="1650" dirty="0"/>
           </a:p>
           <a:p>
-            <a:pPr algn="l" marL="335280" indent="-335280">
+            <a:pPr marL="335280" indent="-335280" algn="l">
               <a:lnSpc>
                 <a:spcPct val="118000"/>
               </a:lnSpc>
@@ -2178,7 +1952,7 @@
             <a:endParaRPr lang="en-US" sz="1650" dirty="0"/>
           </a:p>
           <a:p>
-            <a:pPr algn="l" marL="335280" indent="-335280">
+            <a:pPr marL="335280" indent="-335280" algn="l">
               <a:lnSpc>
                 <a:spcPct val="118000"/>
               </a:lnSpc>
@@ -2199,7 +1973,7 @@
             <a:endParaRPr lang="en-US" sz="1650" dirty="0"/>
           </a:p>
           <a:p>
-            <a:pPr algn="l" marL="335280" indent="-335280">
+            <a:pPr marL="335280" indent="-335280" algn="l">
               <a:lnSpc>
                 <a:spcPct val="118000"/>
               </a:lnSpc>
@@ -2242,7 +2016,7 @@
           <a:bodyPr wrap="none" lIns="0" tIns="0" rIns="0" bIns="0" rtlCol="0" anchor="t"/>
           <a:lstStyle/>
           <a:p>
-            <a:pPr algn="l" indent="0" marL="0">
+            <a:pPr marL="0" indent="0" algn="l">
               <a:lnSpc>
                 <a:spcPct val="118000"/>
               </a:lnSpc>
@@ -2309,14 +2083,14 @@
           <a:bodyPr wrap="none" lIns="0" tIns="0" rIns="0" bIns="0" rtlCol="0" anchor="t"/>
           <a:lstStyle/>
           <a:p>
-            <a:pPr algn="l" indent="0" marL="0">
+            <a:pPr marL="0" indent="0" algn="l">
               <a:lnSpc>
                 <a:spcPct val="104000"/>
               </a:lnSpc>
               <a:buNone/>
             </a:pPr>
             <a:r>
-              <a:rPr lang="en-US" sz="1200" spc="72" kern="100" dirty="0">
+              <a:rPr lang="en-US" sz="1200" kern="100" spc="72" dirty="0">
                 <a:solidFill>
                   <a:srgbClr val="DCE1EE"/>
                 </a:solidFill>
@@ -2353,14 +2127,14 @@
           </a:bodyPr>
           <a:lstStyle/>
           <a:p>
-            <a:pPr algn="l" indent="0" marL="0">
+            <a:pPr marL="0" indent="0" algn="l">
               <a:lnSpc>
                 <a:spcPct val="88000"/>
               </a:lnSpc>
               <a:buNone/>
             </a:pPr>
             <a:r>
-              <a:rPr lang="en-US" sz="3000" spc="-30" kern="100" dirty="0">
+              <a:rPr lang="en-US" sz="3000" kern="100" spc="-30" dirty="0">
                 <a:solidFill>
                   <a:srgbClr val="FFFFFF"/>
                 </a:solidFill>
@@ -2397,7 +2171,7 @@
           </a:bodyPr>
           <a:lstStyle/>
           <a:p>
-            <a:pPr algn="l" marL="335280" indent="-335280">
+            <a:pPr marL="335280" indent="-335280" algn="l">
               <a:lnSpc>
                 <a:spcPct val="118000"/>
               </a:lnSpc>
@@ -2418,7 +2192,7 @@
             <a:endParaRPr lang="en-US" sz="1650" dirty="0"/>
           </a:p>
           <a:p>
-            <a:pPr algn="l" marL="335280" indent="-335280">
+            <a:pPr marL="335280" indent="-335280" algn="l">
               <a:lnSpc>
                 <a:spcPct val="118000"/>
               </a:lnSpc>
@@ -2439,7 +2213,7 @@
             <a:endParaRPr lang="en-US" sz="1650" dirty="0"/>
           </a:p>
           <a:p>
-            <a:pPr algn="l" marL="335280" indent="-335280">
+            <a:pPr marL="335280" indent="-335280" algn="l">
               <a:lnSpc>
                 <a:spcPct val="118000"/>
               </a:lnSpc>
@@ -2460,7 +2234,7 @@
             <a:endParaRPr lang="en-US" sz="1650" dirty="0"/>
           </a:p>
           <a:p>
-            <a:pPr algn="l" marL="335280" indent="-335280">
+            <a:pPr marL="335280" indent="-335280" algn="l">
               <a:lnSpc>
                 <a:spcPct val="118000"/>
               </a:lnSpc>
@@ -2825,7 +2599,7 @@
           <a:bodyPr wrap="none" lIns="0" tIns="0" rIns="0" bIns="0" rtlCol="0" anchor="t"/>
           <a:lstStyle/>
           <a:p>
-            <a:pPr algn="ctr" indent="0" marL="0">
+            <a:pPr marL="0" indent="0" algn="ctr">
               <a:lnSpc>
                 <a:spcPct val="118000"/>
               </a:lnSpc>
@@ -2889,7 +2663,7 @@
           <a:bodyPr wrap="none" lIns="0" tIns="0" rIns="0" bIns="0" rtlCol="0" anchor="t"/>
           <a:lstStyle/>
           <a:p>
-            <a:pPr algn="ctr" indent="0" marL="0">
+            <a:pPr marL="0" indent="0" algn="ctr">
               <a:lnSpc>
                 <a:spcPct val="118000"/>
               </a:lnSpc>
@@ -2955,7 +2729,7 @@
           </a:bodyPr>
           <a:lstStyle/>
           <a:p>
-            <a:pPr algn="ctr" indent="0" marL="0">
+            <a:pPr marL="0" indent="0" algn="ctr">
               <a:lnSpc>
                 <a:spcPct val="118000"/>
               </a:lnSpc>
@@ -3019,7 +2793,7 @@
           <a:bodyPr wrap="none" lIns="0" tIns="0" rIns="0" bIns="0" rtlCol="0" anchor="t"/>
           <a:lstStyle/>
           <a:p>
-            <a:pPr algn="ctr" indent="0" marL="0">
+            <a:pPr marL="0" indent="0" algn="ctr">
               <a:lnSpc>
                 <a:spcPct val="118000"/>
               </a:lnSpc>
@@ -3061,7 +2835,7 @@
           <a:bodyPr wrap="none" lIns="0" tIns="0" rIns="0" bIns="0" rtlCol="0" anchor="t"/>
           <a:lstStyle/>
           <a:p>
-            <a:pPr algn="ctr" indent="0" marL="0">
+            <a:pPr marL="0" indent="0" algn="ctr">
               <a:lnSpc>
                 <a:spcPct val="108000"/>
               </a:lnSpc>
@@ -3125,7 +2899,7 @@
           <a:bodyPr wrap="none" lIns="0" tIns="0" rIns="0" bIns="0" rtlCol="0" anchor="t"/>
           <a:lstStyle/>
           <a:p>
-            <a:pPr algn="ctr" indent="0" marL="0">
+            <a:pPr marL="0" indent="0" algn="ctr">
               <a:lnSpc>
                 <a:spcPct val="118000"/>
               </a:lnSpc>
@@ -3167,7 +2941,7 @@
           <a:bodyPr wrap="none" lIns="0" tIns="0" rIns="0" bIns="0" rtlCol="0" anchor="t"/>
           <a:lstStyle/>
           <a:p>
-            <a:pPr algn="ctr" indent="0" marL="0">
+            <a:pPr marL="0" indent="0" algn="ctr">
               <a:lnSpc>
                 <a:spcPct val="108000"/>
               </a:lnSpc>
@@ -3231,7 +3005,7 @@
           <a:bodyPr wrap="none" lIns="0" tIns="0" rIns="0" bIns="0" rtlCol="0" anchor="t"/>
           <a:lstStyle/>
           <a:p>
-            <a:pPr algn="ctr" indent="0" marL="0">
+            <a:pPr marL="0" indent="0" algn="ctr">
               <a:lnSpc>
                 <a:spcPct val="118000"/>
               </a:lnSpc>
@@ -3275,7 +3049,7 @@
           </a:bodyPr>
           <a:lstStyle/>
           <a:p>
-            <a:pPr algn="ctr" indent="0" marL="0">
+            <a:pPr marL="0" indent="0" algn="ctr">
               <a:lnSpc>
                 <a:spcPct val="108000"/>
               </a:lnSpc>
@@ -3339,7 +3113,7 @@
           <a:bodyPr wrap="none" lIns="0" tIns="0" rIns="0" bIns="0" rtlCol="0" anchor="t"/>
           <a:lstStyle/>
           <a:p>
-            <a:pPr algn="ctr" indent="0" marL="0">
+            <a:pPr marL="0" indent="0" algn="ctr">
               <a:lnSpc>
                 <a:spcPct val="118000"/>
               </a:lnSpc>
@@ -3383,7 +3157,7 @@
           </a:bodyPr>
           <a:lstStyle/>
           <a:p>
-            <a:pPr algn="ctr" indent="0" marL="0">
+            <a:pPr marL="0" indent="0" algn="ctr">
               <a:lnSpc>
                 <a:spcPct val="108000"/>
               </a:lnSpc>
@@ -3450,14 +3224,14 @@
           <a:bodyPr wrap="none" lIns="0" tIns="0" rIns="0" bIns="0" rtlCol="0" anchor="t"/>
           <a:lstStyle/>
           <a:p>
-            <a:pPr algn="l" indent="0" marL="0">
+            <a:pPr marL="0" indent="0" algn="l">
               <a:lnSpc>
                 <a:spcPct val="104000"/>
               </a:lnSpc>
               <a:buNone/>
             </a:pPr>
             <a:r>
-              <a:rPr lang="en-US" sz="1200" spc="72" kern="100" dirty="0">
+              <a:rPr lang="en-US" sz="1200" kern="100" spc="72" dirty="0">
                 <a:solidFill>
                   <a:srgbClr val="A78BFA"/>
                 </a:solidFill>
@@ -3494,14 +3268,14 @@
           </a:bodyPr>
           <a:lstStyle/>
           <a:p>
-            <a:pPr algn="l" indent="0" marL="0">
+            <a:pPr marL="0" indent="0" algn="l">
               <a:lnSpc>
                 <a:spcPct val="88000"/>
               </a:lnSpc>
               <a:buNone/>
             </a:pPr>
             <a:r>
-              <a:rPr lang="en-US" sz="3000" spc="-30" kern="100" dirty="0">
+              <a:rPr lang="en-US" sz="3000" kern="100" spc="-30" dirty="0">
                 <a:solidFill>
                   <a:srgbClr val="FFFFFF"/>
                 </a:solidFill>
@@ -3538,7 +3312,7 @@
           </a:bodyPr>
           <a:lstStyle/>
           <a:p>
-            <a:pPr algn="l" marL="335280" indent="-335280">
+            <a:pPr marL="335280" indent="-335280" algn="l">
               <a:lnSpc>
                 <a:spcPct val="118000"/>
               </a:lnSpc>
@@ -3559,7 +3333,7 @@
             <a:endParaRPr lang="en-US" sz="1650" dirty="0"/>
           </a:p>
           <a:p>
-            <a:pPr algn="l" marL="335280" indent="-335280">
+            <a:pPr marL="335280" indent="-335280" algn="l">
               <a:lnSpc>
                 <a:spcPct val="118000"/>
               </a:lnSpc>
@@ -3580,7 +3354,7 @@
             <a:endParaRPr lang="en-US" sz="1650" dirty="0"/>
           </a:p>
           <a:p>
-            <a:pPr algn="l" marL="335280" indent="-335280">
+            <a:pPr marL="335280" indent="-335280" algn="l">
               <a:lnSpc>
                 <a:spcPct val="118000"/>
               </a:lnSpc>
@@ -3601,7 +3375,7 @@
             <a:endParaRPr lang="en-US" sz="1650" dirty="0"/>
           </a:p>
           <a:p>
-            <a:pPr algn="l" marL="335280" indent="-335280">
+            <a:pPr marL="335280" indent="-335280" algn="l">
               <a:lnSpc>
                 <a:spcPct val="118000"/>
               </a:lnSpc>
@@ -3646,7 +3420,7 @@
           </a:bodyPr>
           <a:lstStyle/>
           <a:p>
-            <a:pPr algn="l" indent="0" marL="0">
+            <a:pPr marL="0" indent="0" algn="l">
               <a:lnSpc>
                 <a:spcPct val="118000"/>
               </a:lnSpc>
@@ -3669,14 +3443,14 @@
       </p:sp>
       <p:pic>
         <p:nvPicPr>
-          <p:cNvPr id="6" name="Image 0" descr="preencoded.png">    </p:cNvPr>
+          <p:cNvPr id="6" name="Image 0" descr="preencoded.png"/>
           <p:cNvPicPr>
             <a:picLocks noChangeAspect="1"/>
           </p:cNvPicPr>
           <p:nvPr/>
         </p:nvPicPr>
         <p:blipFill>
-          <a:blip r:embed="rId1"/>
+          <a:blip r:embed="rId3"/>
           <a:stretch>
             <a:fillRect/>
           </a:stretch>
@@ -3737,14 +3511,14 @@
           <a:bodyPr wrap="none" lIns="0" tIns="0" rIns="0" bIns="0" rtlCol="0" anchor="t"/>
           <a:lstStyle/>
           <a:p>
-            <a:pPr algn="l" indent="0" marL="0">
+            <a:pPr marL="0" indent="0" algn="l">
               <a:lnSpc>
                 <a:spcPct val="104000"/>
               </a:lnSpc>
               <a:buNone/>
             </a:pPr>
             <a:r>
-              <a:rPr lang="en-US" sz="1200" spc="72" kern="100" dirty="0">
+              <a:rPr lang="en-US" sz="1200" kern="100" spc="72" dirty="0">
                 <a:solidFill>
                   <a:srgbClr val="A78BFA"/>
                 </a:solidFill>
@@ -3781,14 +3555,14 @@
           </a:bodyPr>
           <a:lstStyle/>
           <a:p>
-            <a:pPr algn="l" indent="0" marL="0">
+            <a:pPr marL="0" indent="0" algn="l">
               <a:lnSpc>
                 <a:spcPct val="88000"/>
               </a:lnSpc>
               <a:buNone/>
             </a:pPr>
             <a:r>
-              <a:rPr lang="en-US" sz="3000" spc="-30" kern="100" dirty="0">
+              <a:rPr lang="en-US" sz="3000" kern="100" spc="-30" dirty="0">
                 <a:solidFill>
                   <a:srgbClr val="FFFFFF"/>
                 </a:solidFill>
@@ -3825,8 +3599,20 @@
             <a:tbl>
               <a:tblPr/>
               <a:tblGrid>
-                <a:gridCol w="2039986"/>
-                <a:gridCol w="4335255"/>
+                <a:gridCol w="2039986">
+                  <a:extLst>
+                    <a:ext uri="{9D8B030D-6E8A-4147-A177-3AD203B41FA5}">
+                      <a16:colId xmlns:a16="http://schemas.microsoft.com/office/drawing/2014/main" val="20000"/>
+                    </a:ext>
+                  </a:extLst>
+                </a:gridCol>
+                <a:gridCol w="4335255">
+                  <a:extLst>
+                    <a:ext uri="{9D8B030D-6E8A-4147-A177-3AD203B41FA5}">
+                      <a16:colId xmlns:a16="http://schemas.microsoft.com/office/drawing/2014/main" val="20001"/>
+                    </a:ext>
+                  </a:extLst>
+                </a:gridCol>
               </a:tblGrid>
               <a:tr h="477726">
                 <a:tc>
@@ -3834,11 +3620,11 @@
                     <a:bodyPr/>
                     <a:lstStyle/>
                     <a:p>
-                      <a:pPr algn="l" indent="0" marL="0">
+                      <a:pPr marL="0" indent="0" algn="l">
                         <a:buNone/>
                       </a:pPr>
                       <a:r>
-                        <a:rPr lang="en-US" sz="1650" spc="99" kern="100" dirty="0">
+                        <a:rPr lang="en-US" sz="1650" kern="100" spc="99" dirty="0">
                           <a:solidFill>
                             <a:srgbClr val="FFFFFF"/>
                           </a:solidFill>
@@ -3899,11 +3685,11 @@
                     <a:bodyPr/>
                     <a:lstStyle/>
                     <a:p>
-                      <a:pPr algn="l" indent="0" marL="0">
+                      <a:pPr marL="0" indent="0" algn="l">
                         <a:buNone/>
                       </a:pPr>
                       <a:r>
-                        <a:rPr lang="en-US" sz="1650" spc="99" kern="100" dirty="0">
+                        <a:rPr lang="en-US" sz="1650" kern="100" spc="99" dirty="0">
                           <a:solidFill>
                             <a:srgbClr val="FFFFFF"/>
                           </a:solidFill>
@@ -3959,6 +3745,11 @@
                     </a:lnB>
                   </a:tcPr>
                 </a:tc>
+                <a:extLst>
+                  <a:ext uri="{0D108BD9-81ED-4DB2-BD59-A6C34878D82A}">
+                    <a16:rowId xmlns:a16="http://schemas.microsoft.com/office/drawing/2014/main" val="10000"/>
+                  </a:ext>
+                </a:extLst>
               </a:tr>
               <a:tr h="703046">
                 <a:tc>
@@ -3966,7 +3757,7 @@
                     <a:bodyPr/>
                     <a:lstStyle/>
                     <a:p>
-                      <a:pPr algn="l" indent="0" marL="0">
+                      <a:pPr marL="0" indent="0" algn="l">
                         <a:buNone/>
                       </a:pPr>
                       <a:r>
@@ -4031,7 +3822,7 @@
                     <a:bodyPr/>
                     <a:lstStyle/>
                     <a:p>
-                      <a:pPr algn="l" indent="0" marL="0">
+                      <a:pPr marL="0" indent="0" algn="l">
                         <a:buNone/>
                       </a:pPr>
                       <a:r>
@@ -4091,6 +3882,11 @@
                     </a:lnB>
                   </a:tcPr>
                 </a:tc>
+                <a:extLst>
+                  <a:ext uri="{0D108BD9-81ED-4DB2-BD59-A6C34878D82A}">
+                    <a16:rowId xmlns:a16="http://schemas.microsoft.com/office/drawing/2014/main" val="10001"/>
+                  </a:ext>
+                </a:extLst>
               </a:tr>
               <a:tr h="441612">
                 <a:tc>
@@ -4098,7 +3894,7 @@
                     <a:bodyPr/>
                     <a:lstStyle/>
                     <a:p>
-                      <a:pPr algn="l" indent="0" marL="0">
+                      <a:pPr marL="0" indent="0" algn="l">
                         <a:buNone/>
                       </a:pPr>
                       <a:r>
@@ -4163,7 +3959,7 @@
                     <a:bodyPr/>
                     <a:lstStyle/>
                     <a:p>
-                      <a:pPr algn="l" indent="0" marL="0">
+                      <a:pPr marL="0" indent="0" algn="l">
                         <a:buNone/>
                       </a:pPr>
                       <a:r>
@@ -4223,6 +4019,11 @@
                     </a:lnB>
                   </a:tcPr>
                 </a:tc>
+                <a:extLst>
+                  <a:ext uri="{0D108BD9-81ED-4DB2-BD59-A6C34878D82A}">
+                    <a16:rowId xmlns:a16="http://schemas.microsoft.com/office/drawing/2014/main" val="10002"/>
+                  </a:ext>
+                </a:extLst>
               </a:tr>
               <a:tr h="428912">
                 <a:tc>
@@ -4230,7 +4031,7 @@
                     <a:bodyPr/>
                     <a:lstStyle/>
                     <a:p>
-                      <a:pPr algn="l" indent="0" marL="0">
+                      <a:pPr marL="0" indent="0" algn="l">
                         <a:buNone/>
                       </a:pPr>
                       <a:r>
@@ -4295,7 +4096,7 @@
                     <a:bodyPr/>
                     <a:lstStyle/>
                     <a:p>
-                      <a:pPr algn="l" indent="0" marL="0">
+                      <a:pPr marL="0" indent="0" algn="l">
                         <a:buNone/>
                       </a:pPr>
                       <a:r>
@@ -4355,6 +4156,11 @@
                     </a:lnB>
                   </a:tcPr>
                 </a:tc>
+                <a:extLst>
+                  <a:ext uri="{0D108BD9-81ED-4DB2-BD59-A6C34878D82A}">
+                    <a16:rowId xmlns:a16="http://schemas.microsoft.com/office/drawing/2014/main" val="10003"/>
+                  </a:ext>
+                </a:extLst>
               </a:tr>
             </a:tbl>
           </a:graphicData>
@@ -4362,7 +4168,7 @@
       </p:graphicFrame>
       <p:sp>
         <p:nvSpPr>
-          <p:cNvPr id="5" name="Text 2"/>
+          <p:cNvPr id="4" name="Text 2"/>
           <p:cNvSpPr/>
           <p:nvPr/>
         </p:nvSpPr>
@@ -4381,7 +4187,7 @@
           <a:bodyPr wrap="none" lIns="0" tIns="0" rIns="0" bIns="0" rtlCol="0" anchor="t"/>
           <a:lstStyle/>
           <a:p>
-            <a:pPr algn="l" indent="0" marL="0">
+            <a:pPr marL="0" indent="0" algn="l">
               <a:lnSpc>
                 <a:spcPct val="108000"/>
               </a:lnSpc>
@@ -4425,7 +4231,7 @@
           </a:bodyPr>
           <a:lstStyle/>
           <a:p>
-            <a:pPr algn="l" marL="335280" indent="-335280">
+            <a:pPr marL="335280" indent="-335280" algn="l">
               <a:lnSpc>
                 <a:spcPct val="118000"/>
               </a:lnSpc>
@@ -4446,7 +4252,7 @@
             <a:endParaRPr lang="en-US" sz="1650" dirty="0"/>
           </a:p>
           <a:p>
-            <a:pPr algn="l" marL="335280" indent="-335280">
+            <a:pPr marL="335280" indent="-335280" algn="l">
               <a:lnSpc>
                 <a:spcPct val="118000"/>
               </a:lnSpc>
@@ -4467,7 +4273,7 @@
             <a:endParaRPr lang="en-US" sz="1650" dirty="0"/>
           </a:p>
           <a:p>
-            <a:pPr algn="l" marL="335280" indent="-335280">
+            <a:pPr marL="335280" indent="-335280" algn="l">
               <a:lnSpc>
                 <a:spcPct val="118000"/>
               </a:lnSpc>
@@ -4488,7 +4294,7 @@
             <a:endParaRPr lang="en-US" sz="1650" dirty="0"/>
           </a:p>
           <a:p>
-            <a:pPr algn="l" marL="335280" indent="-335280">
+            <a:pPr marL="335280" indent="-335280" algn="l">
               <a:lnSpc>
                 <a:spcPct val="118000"/>
               </a:lnSpc>
@@ -4533,7 +4339,7 @@
           </a:bodyPr>
           <a:lstStyle/>
           <a:p>
-            <a:pPr algn="l" indent="0" marL="0">
+            <a:pPr marL="0" indent="0" algn="l">
               <a:lnSpc>
                 <a:spcPct val="118000"/>
               </a:lnSpc>
@@ -4556,7 +4362,7 @@
             <a:endParaRPr lang="en-US" sz="1450" dirty="0"/>
           </a:p>
           <a:p>
-            <a:pPr algn="l" indent="0" marL="0">
+            <a:pPr marL="0" indent="0" algn="l">
               <a:lnSpc>
                 <a:spcPct val="118000"/>
               </a:lnSpc>
@@ -4623,14 +4429,14 @@
           <a:bodyPr wrap="none" lIns="0" tIns="0" rIns="0" bIns="0" rtlCol="0" anchor="t"/>
           <a:lstStyle/>
           <a:p>
-            <a:pPr algn="l" indent="0" marL="0">
+            <a:pPr marL="0" indent="0" algn="l">
               <a:lnSpc>
                 <a:spcPct val="104000"/>
               </a:lnSpc>
               <a:buNone/>
             </a:pPr>
             <a:r>
-              <a:rPr lang="en-US" sz="1200" spc="72" kern="100" dirty="0">
+              <a:rPr lang="en-US" sz="1200" kern="100" spc="72" dirty="0">
                 <a:solidFill>
                   <a:srgbClr val="A78BFA"/>
                 </a:solidFill>
@@ -4665,14 +4471,14 @@
           <a:bodyPr wrap="none" lIns="0" tIns="0" rIns="0" bIns="0" rtlCol="0" anchor="t"/>
           <a:lstStyle/>
           <a:p>
-            <a:pPr algn="l" indent="0" marL="0">
+            <a:pPr marL="0" indent="0" algn="l">
               <a:lnSpc>
                 <a:spcPct val="88000"/>
               </a:lnSpc>
               <a:buNone/>
             </a:pPr>
             <a:r>
-              <a:rPr lang="en-US" sz="3000" spc="-30" kern="100" dirty="0">
+              <a:rPr lang="en-US" sz="3000" kern="100" spc="-30" dirty="0">
                 <a:solidFill>
                   <a:srgbClr val="FFFFFF"/>
                 </a:solidFill>
@@ -4688,14 +4494,14 @@
       </p:sp>
       <p:pic>
         <p:nvPicPr>
-          <p:cNvPr id="4" name="Image 0" descr="preencoded.png">    </p:cNvPr>
+          <p:cNvPr id="4" name="Image 0" descr="preencoded.png"/>
           <p:cNvPicPr>
             <a:picLocks noChangeAspect="1"/>
           </p:cNvPicPr>
           <p:nvPr/>
         </p:nvPicPr>
         <p:blipFill>
-          <a:blip r:embed="rId1"/>
+          <a:blip r:embed="rId3"/>
           <a:stretch>
             <a:fillRect/>
           </a:stretch>
@@ -4733,8 +4539,20 @@
             <a:tbl>
               <a:tblPr/>
               <a:tblGrid>
-                <a:gridCol w="2394982"/>
-                <a:gridCol w="4649175"/>
+                <a:gridCol w="2394982">
+                  <a:extLst>
+                    <a:ext uri="{9D8B030D-6E8A-4147-A177-3AD203B41FA5}">
+                      <a16:colId xmlns:a16="http://schemas.microsoft.com/office/drawing/2014/main" val="20000"/>
+                    </a:ext>
+                  </a:extLst>
+                </a:gridCol>
+                <a:gridCol w="4649175">
+                  <a:extLst>
+                    <a:ext uri="{9D8B030D-6E8A-4147-A177-3AD203B41FA5}">
+                      <a16:colId xmlns:a16="http://schemas.microsoft.com/office/drawing/2014/main" val="20001"/>
+                    </a:ext>
+                  </a:extLst>
+                </a:gridCol>
               </a:tblGrid>
               <a:tr h="477726">
                 <a:tc>
@@ -4742,11 +4560,11 @@
                     <a:bodyPr/>
                     <a:lstStyle/>
                     <a:p>
-                      <a:pPr algn="l" indent="0" marL="0">
+                      <a:pPr marL="0" indent="0" algn="l">
                         <a:buNone/>
                       </a:pPr>
                       <a:r>
-                        <a:rPr lang="en-US" sz="1650" spc="99" kern="100" dirty="0">
+                        <a:rPr lang="en-US" sz="1650" kern="100" spc="99" dirty="0">
                           <a:solidFill>
                             <a:srgbClr val="FFFFFF"/>
                           </a:solidFill>
@@ -4807,11 +4625,11 @@
                     <a:bodyPr/>
                     <a:lstStyle/>
                     <a:p>
-                      <a:pPr algn="l" indent="0" marL="0">
+                      <a:pPr marL="0" indent="0" algn="l">
                         <a:buNone/>
                       </a:pPr>
                       <a:r>
-                        <a:rPr lang="en-US" sz="1650" spc="99" kern="100" dirty="0">
+                        <a:rPr lang="en-US" sz="1650" kern="100" spc="99" dirty="0">
                           <a:solidFill>
                             <a:srgbClr val="FFFFFF"/>
                           </a:solidFill>
@@ -4867,6 +4685,11 @@
                     </a:lnB>
                   </a:tcPr>
                 </a:tc>
+                <a:extLst>
+                  <a:ext uri="{0D108BD9-81ED-4DB2-BD59-A6C34878D82A}">
+                    <a16:rowId xmlns:a16="http://schemas.microsoft.com/office/drawing/2014/main" val="10000"/>
+                  </a:ext>
+                </a:extLst>
               </a:tr>
               <a:tr h="441612">
                 <a:tc>
@@ -4874,7 +4697,7 @@
                     <a:bodyPr/>
                     <a:lstStyle/>
                     <a:p>
-                      <a:pPr algn="l" indent="0" marL="0">
+                      <a:pPr marL="0" indent="0" algn="l">
                         <a:buNone/>
                       </a:pPr>
                       <a:r>
@@ -4939,7 +4762,7 @@
                     <a:bodyPr/>
                     <a:lstStyle/>
                     <a:p>
-                      <a:pPr algn="l" indent="0" marL="0">
+                      <a:pPr marL="0" indent="0" algn="l">
                         <a:buNone/>
                       </a:pPr>
                       <a:r>
@@ -4999,6 +4822,11 @@
                     </a:lnB>
                   </a:tcPr>
                 </a:tc>
+                <a:extLst>
+                  <a:ext uri="{0D108BD9-81ED-4DB2-BD59-A6C34878D82A}">
+                    <a16:rowId xmlns:a16="http://schemas.microsoft.com/office/drawing/2014/main" val="10001"/>
+                  </a:ext>
+                </a:extLst>
               </a:tr>
               <a:tr h="703046">
                 <a:tc>
@@ -5006,7 +4834,7 @@
                     <a:bodyPr/>
                     <a:lstStyle/>
                     <a:p>
-                      <a:pPr algn="l" indent="0" marL="0">
+                      <a:pPr marL="0" indent="0" algn="l">
                         <a:buNone/>
                       </a:pPr>
                       <a:r>
@@ -5071,7 +4899,7 @@
                     <a:bodyPr/>
                     <a:lstStyle/>
                     <a:p>
-                      <a:pPr algn="l" indent="0" marL="0">
+                      <a:pPr marL="0" indent="0" algn="l">
                         <a:buNone/>
                       </a:pPr>
                       <a:r>
@@ -5131,6 +4959,11 @@
                     </a:lnB>
                   </a:tcPr>
                 </a:tc>
+                <a:extLst>
+                  <a:ext uri="{0D108BD9-81ED-4DB2-BD59-A6C34878D82A}">
+                    <a16:rowId xmlns:a16="http://schemas.microsoft.com/office/drawing/2014/main" val="10002"/>
+                  </a:ext>
+                </a:extLst>
               </a:tr>
               <a:tr h="703046">
                 <a:tc>
@@ -5138,7 +4971,7 @@
                     <a:bodyPr/>
                     <a:lstStyle/>
                     <a:p>
-                      <a:pPr algn="l" indent="0" marL="0">
+                      <a:pPr marL="0" indent="0" algn="l">
                         <a:buNone/>
                       </a:pPr>
                       <a:r>
@@ -5203,7 +5036,7 @@
                     <a:bodyPr/>
                     <a:lstStyle/>
                     <a:p>
-                      <a:pPr algn="l" indent="0" marL="0">
+                      <a:pPr marL="0" indent="0" algn="l">
                         <a:buNone/>
                       </a:pPr>
                       <a:r>
@@ -5263,6 +5096,11 @@
                     </a:lnB>
                   </a:tcPr>
                 </a:tc>
+                <a:extLst>
+                  <a:ext uri="{0D108BD9-81ED-4DB2-BD59-A6C34878D82A}">
+                    <a16:rowId xmlns:a16="http://schemas.microsoft.com/office/drawing/2014/main" val="10003"/>
+                  </a:ext>
+                </a:extLst>
               </a:tr>
               <a:tr h="703046">
                 <a:tc>
@@ -5270,7 +5108,7 @@
                     <a:bodyPr/>
                     <a:lstStyle/>
                     <a:p>
-                      <a:pPr algn="l" indent="0" marL="0">
+                      <a:pPr marL="0" indent="0" algn="l">
                         <a:buNone/>
                       </a:pPr>
                       <a:r>
@@ -5335,7 +5173,7 @@
                     <a:bodyPr/>
                     <a:lstStyle/>
                     <a:p>
-                      <a:pPr algn="l" indent="0" marL="0">
+                      <a:pPr marL="0" indent="0" algn="l">
                         <a:buNone/>
                       </a:pPr>
                       <a:r>
@@ -5395,6 +5233,11 @@
                     </a:lnB>
                   </a:tcPr>
                 </a:tc>
+                <a:extLst>
+                  <a:ext uri="{0D108BD9-81ED-4DB2-BD59-A6C34878D82A}">
+                    <a16:rowId xmlns:a16="http://schemas.microsoft.com/office/drawing/2014/main" val="10004"/>
+                  </a:ext>
+                </a:extLst>
               </a:tr>
               <a:tr h="428912">
                 <a:tc>
@@ -5402,7 +5245,7 @@
                     <a:bodyPr/>
                     <a:lstStyle/>
                     <a:p>
-                      <a:pPr algn="l" indent="0" marL="0">
+                      <a:pPr marL="0" indent="0" algn="l">
                         <a:buNone/>
                       </a:pPr>
                       <a:r>
@@ -5467,7 +5310,7 @@
                     <a:bodyPr/>
                     <a:lstStyle/>
                     <a:p>
-                      <a:pPr algn="l" indent="0" marL="0">
+                      <a:pPr marL="0" indent="0" algn="l">
                         <a:buNone/>
                       </a:pPr>
                       <a:r>
@@ -5527,6 +5370,11 @@
                     </a:lnB>
                   </a:tcPr>
                 </a:tc>
+                <a:extLst>
+                  <a:ext uri="{0D108BD9-81ED-4DB2-BD59-A6C34878D82A}">
+                    <a16:rowId xmlns:a16="http://schemas.microsoft.com/office/drawing/2014/main" val="10005"/>
+                  </a:ext>
+                </a:extLst>
               </a:tr>
             </a:tbl>
           </a:graphicData>
@@ -5534,7 +5382,7 @@
       </p:graphicFrame>
       <p:sp>
         <p:nvSpPr>
-          <p:cNvPr id="6" name="Text 2"/>
+          <p:cNvPr id="5" name="Text 2"/>
           <p:cNvSpPr/>
           <p:nvPr/>
         </p:nvSpPr>
@@ -5553,7 +5401,7 @@
           <a:bodyPr wrap="none" lIns="0" tIns="0" rIns="0" bIns="0" rtlCol="0" anchor="t"/>
           <a:lstStyle/>
           <a:p>
-            <a:pPr algn="l" indent="0" marL="0">
+            <a:pPr marL="0" indent="0" algn="l">
               <a:lnSpc>
                 <a:spcPct val="118000"/>
               </a:lnSpc>
@@ -5620,14 +5468,14 @@
           <a:bodyPr wrap="none" lIns="0" tIns="0" rIns="0" bIns="0" rtlCol="0" anchor="t"/>
           <a:lstStyle/>
           <a:p>
-            <a:pPr algn="l" indent="0" marL="0">
+            <a:pPr marL="0" indent="0" algn="l">
               <a:lnSpc>
                 <a:spcPct val="104000"/>
               </a:lnSpc>
               <a:buNone/>
             </a:pPr>
             <a:r>
-              <a:rPr lang="en-US" sz="1200" spc="72" kern="100" dirty="0">
+              <a:rPr lang="en-US" sz="1200" kern="100" spc="72" dirty="0">
                 <a:solidFill>
                   <a:srgbClr val="EB5324"/>
                 </a:solidFill>
@@ -5664,14 +5512,14 @@
           </a:bodyPr>
           <a:lstStyle/>
           <a:p>
-            <a:pPr algn="l" indent="0" marL="0">
+            <a:pPr marL="0" indent="0" algn="l">
               <a:lnSpc>
                 <a:spcPct val="88000"/>
               </a:lnSpc>
               <a:buNone/>
             </a:pPr>
             <a:r>
-              <a:rPr lang="en-US" sz="3000" spc="-30" kern="100" dirty="0">
+              <a:rPr lang="en-US" sz="3000" kern="100" spc="-30" dirty="0">
                 <a:solidFill>
                   <a:srgbClr val="FFFFFF"/>
                 </a:solidFill>
@@ -5708,7 +5556,7 @@
           </a:bodyPr>
           <a:lstStyle/>
           <a:p>
-            <a:pPr algn="l" marL="335280" indent="-335280">
+            <a:pPr marL="335280" indent="-335280" algn="l">
               <a:lnSpc>
                 <a:spcPct val="118000"/>
               </a:lnSpc>
@@ -5729,7 +5577,7 @@
             <a:endParaRPr lang="en-US" sz="1650" dirty="0"/>
           </a:p>
           <a:p>
-            <a:pPr algn="l" marL="335280" indent="-335280">
+            <a:pPr marL="335280" indent="-335280" algn="l">
               <a:lnSpc>
                 <a:spcPct val="118000"/>
               </a:lnSpc>
@@ -5750,7 +5598,7 @@
             <a:endParaRPr lang="en-US" sz="1650" dirty="0"/>
           </a:p>
           <a:p>
-            <a:pPr algn="l" marL="335280" indent="-335280">
+            <a:pPr marL="335280" indent="-335280" algn="l">
               <a:lnSpc>
                 <a:spcPct val="118000"/>
               </a:lnSpc>
@@ -5771,7 +5619,7 @@
             <a:endParaRPr lang="en-US" sz="1650" dirty="0"/>
           </a:p>
           <a:p>
-            <a:pPr algn="l" marL="335280" indent="-335280">
+            <a:pPr marL="335280" indent="-335280" algn="l">
               <a:lnSpc>
                 <a:spcPct val="118000"/>
               </a:lnSpc>
@@ -5816,7 +5664,7 @@
           </a:bodyPr>
           <a:lstStyle/>
           <a:p>
-            <a:pPr algn="l" indent="0" marL="0">
+            <a:pPr marL="0" indent="0" algn="l">
               <a:lnSpc>
                 <a:spcPct val="118000"/>
               </a:lnSpc>
@@ -5839,14 +5687,14 @@
       </p:sp>
       <p:pic>
         <p:nvPicPr>
-          <p:cNvPr id="6" name="Image 0" descr="preencoded.png">    </p:cNvPr>
+          <p:cNvPr id="6" name="Image 0" descr="preencoded.png"/>
           <p:cNvPicPr>
             <a:picLocks noChangeAspect="1"/>
           </p:cNvPicPr>
           <p:nvPr/>
         </p:nvPicPr>
         <p:blipFill>
-          <a:blip r:embed="rId1"/>
+          <a:blip r:embed="rId3"/>
           <a:stretch>
             <a:fillRect/>
           </a:stretch>
@@ -5907,14 +5755,14 @@
           <a:bodyPr wrap="none" lIns="0" tIns="0" rIns="0" bIns="0" rtlCol="0" anchor="t"/>
           <a:lstStyle/>
           <a:p>
-            <a:pPr algn="l" indent="0" marL="0">
+            <a:pPr marL="0" indent="0" algn="l">
               <a:lnSpc>
                 <a:spcPct val="104000"/>
               </a:lnSpc>
               <a:buNone/>
             </a:pPr>
             <a:r>
-              <a:rPr lang="en-US" sz="1200" spc="72" kern="100" dirty="0">
+              <a:rPr lang="en-US" sz="1200" kern="100" spc="72" dirty="0">
                 <a:solidFill>
                   <a:srgbClr val="EB5324"/>
                 </a:solidFill>
@@ -5949,14 +5797,14 @@
           <a:bodyPr wrap="none" lIns="0" tIns="0" rIns="0" bIns="0" rtlCol="0" anchor="t"/>
           <a:lstStyle/>
           <a:p>
-            <a:pPr algn="l" indent="0" marL="0">
+            <a:pPr marL="0" indent="0" algn="l">
               <a:lnSpc>
                 <a:spcPct val="88000"/>
               </a:lnSpc>
               <a:buNone/>
             </a:pPr>
             <a:r>
-              <a:rPr lang="en-US" sz="3000" spc="-30" kern="100" dirty="0">
+              <a:rPr lang="en-US" sz="3000" kern="100" spc="-30" dirty="0">
                 <a:solidFill>
                   <a:srgbClr val="FFFFFF"/>
                 </a:solidFill>
@@ -5993,8 +5841,20 @@
             <a:tbl>
               <a:tblPr/>
               <a:tblGrid>
-                <a:gridCol w="2535869"/>
-                <a:gridCol w="3803853"/>
+                <a:gridCol w="2535869">
+                  <a:extLst>
+                    <a:ext uri="{9D8B030D-6E8A-4147-A177-3AD203B41FA5}">
+                      <a16:colId xmlns:a16="http://schemas.microsoft.com/office/drawing/2014/main" val="20000"/>
+                    </a:ext>
+                  </a:extLst>
+                </a:gridCol>
+                <a:gridCol w="3803853">
+                  <a:extLst>
+                    <a:ext uri="{9D8B030D-6E8A-4147-A177-3AD203B41FA5}">
+                      <a16:colId xmlns:a16="http://schemas.microsoft.com/office/drawing/2014/main" val="20001"/>
+                    </a:ext>
+                  </a:extLst>
+                </a:gridCol>
               </a:tblGrid>
               <a:tr h="477726">
                 <a:tc>
@@ -6002,11 +5862,11 @@
                     <a:bodyPr/>
                     <a:lstStyle/>
                     <a:p>
-                      <a:pPr algn="l" indent="0" marL="0">
+                      <a:pPr marL="0" indent="0" algn="l">
                         <a:buNone/>
                       </a:pPr>
                       <a:r>
-                        <a:rPr lang="en-US" sz="1650" spc="99" kern="100" dirty="0">
+                        <a:rPr lang="en-US" sz="1650" kern="100" spc="99" dirty="0">
                           <a:solidFill>
                             <a:srgbClr val="FFFFFF"/>
                           </a:solidFill>
@@ -6067,11 +5927,11 @@
                     <a:bodyPr/>
                     <a:lstStyle/>
                     <a:p>
-                      <a:pPr algn="l" indent="0" marL="0">
+                      <a:pPr marL="0" indent="0" algn="l">
                         <a:buNone/>
                       </a:pPr>
                       <a:r>
-                        <a:rPr lang="en-US" sz="1650" spc="99" kern="100" dirty="0">
+                        <a:rPr lang="en-US" sz="1650" kern="100" spc="99" dirty="0">
                           <a:solidFill>
                             <a:srgbClr val="FFFFFF"/>
                           </a:solidFill>
@@ -6127,6 +5987,11 @@
                     </a:lnB>
                   </a:tcPr>
                 </a:tc>
+                <a:extLst>
+                  <a:ext uri="{0D108BD9-81ED-4DB2-BD59-A6C34878D82A}">
+                    <a16:rowId xmlns:a16="http://schemas.microsoft.com/office/drawing/2014/main" val="10000"/>
+                  </a:ext>
+                </a:extLst>
               </a:tr>
               <a:tr h="441612">
                 <a:tc>
@@ -6134,7 +5999,7 @@
                     <a:bodyPr/>
                     <a:lstStyle/>
                     <a:p>
-                      <a:pPr algn="l" indent="0" marL="0">
+                      <a:pPr marL="0" indent="0" algn="l">
                         <a:buNone/>
                       </a:pPr>
                       <a:r>
@@ -6199,7 +6064,7 @@
                     <a:bodyPr/>
                     <a:lstStyle/>
                     <a:p>
-                      <a:pPr algn="l" indent="0" marL="0">
+                      <a:pPr marL="0" indent="0" algn="l">
                         <a:buNone/>
                       </a:pPr>
                       <a:r>
@@ -6259,6 +6124,11 @@
                     </a:lnB>
                   </a:tcPr>
                 </a:tc>
+                <a:extLst>
+                  <a:ext uri="{0D108BD9-81ED-4DB2-BD59-A6C34878D82A}">
+                    <a16:rowId xmlns:a16="http://schemas.microsoft.com/office/drawing/2014/main" val="10001"/>
+                  </a:ext>
+                </a:extLst>
               </a:tr>
               <a:tr h="703046">
                 <a:tc>
@@ -6266,7 +6136,7 @@
                     <a:bodyPr/>
                     <a:lstStyle/>
                     <a:p>
-                      <a:pPr algn="l" indent="0" marL="0">
+                      <a:pPr marL="0" indent="0" algn="l">
                         <a:buNone/>
                       </a:pPr>
                       <a:r>
@@ -6331,7 +6201,7 @@
                     <a:bodyPr/>
                     <a:lstStyle/>
                     <a:p>
-                      <a:pPr algn="l" indent="0" marL="0">
+                      <a:pPr marL="0" indent="0" algn="l">
                         <a:buNone/>
                       </a:pPr>
                       <a:r>
@@ -6391,6 +6261,11 @@
                     </a:lnB>
                   </a:tcPr>
                 </a:tc>
+                <a:extLst>
+                  <a:ext uri="{0D108BD9-81ED-4DB2-BD59-A6C34878D82A}">
+                    <a16:rowId xmlns:a16="http://schemas.microsoft.com/office/drawing/2014/main" val="10002"/>
+                  </a:ext>
+                </a:extLst>
               </a:tr>
               <a:tr h="690347">
                 <a:tc>
@@ -6398,7 +6273,7 @@
                     <a:bodyPr/>
                     <a:lstStyle/>
                     <a:p>
-                      <a:pPr algn="l" indent="0" marL="0">
+                      <a:pPr marL="0" indent="0" algn="l">
                         <a:buNone/>
                       </a:pPr>
                       <a:r>
@@ -6463,7 +6338,7 @@
                     <a:bodyPr/>
                     <a:lstStyle/>
                     <a:p>
-                      <a:pPr algn="l" indent="0" marL="0">
+                      <a:pPr marL="0" indent="0" algn="l">
                         <a:buNone/>
                       </a:pPr>
                       <a:r>
@@ -6523,6 +6398,11 @@
                     </a:lnB>
                   </a:tcPr>
                 </a:tc>
+                <a:extLst>
+                  <a:ext uri="{0D108BD9-81ED-4DB2-BD59-A6C34878D82A}">
+                    <a16:rowId xmlns:a16="http://schemas.microsoft.com/office/drawing/2014/main" val="10003"/>
+                  </a:ext>
+                </a:extLst>
               </a:tr>
             </a:tbl>
           </a:graphicData>
@@ -6549,7 +6429,7 @@
           <a:bodyPr wrap="none" lIns="0" tIns="0" rIns="0" bIns="0" rtlCol="0" anchor="t"/>
           <a:lstStyle/>
           <a:p>
-            <a:pPr algn="l" indent="0" marL="0">
+            <a:pPr marL="0" indent="0" algn="l">
               <a:lnSpc>
                 <a:spcPct val="108000"/>
               </a:lnSpc>
@@ -6593,7 +6473,7 @@
           </a:bodyPr>
           <a:lstStyle/>
           <a:p>
-            <a:pPr algn="l" marL="335280" indent="-335280">
+            <a:pPr marL="335280" indent="-335280" algn="l">
               <a:lnSpc>
                 <a:spcPct val="118000"/>
               </a:lnSpc>
@@ -6614,7 +6494,7 @@
             <a:endParaRPr lang="en-US" sz="1650" dirty="0"/>
           </a:p>
           <a:p>
-            <a:pPr algn="l" marL="335280" indent="-335280">
+            <a:pPr marL="335280" indent="-335280" algn="l">
               <a:lnSpc>
                 <a:spcPct val="118000"/>
               </a:lnSpc>
@@ -6635,7 +6515,7 @@
             <a:endParaRPr lang="en-US" sz="1650" dirty="0"/>
           </a:p>
           <a:p>
-            <a:pPr algn="l" marL="335280" indent="-335280">
+            <a:pPr marL="335280" indent="-335280" algn="l">
               <a:lnSpc>
                 <a:spcPct val="118000"/>
               </a:lnSpc>
@@ -6656,7 +6536,7 @@
             <a:endParaRPr lang="en-US" sz="1650" dirty="0"/>
           </a:p>
           <a:p>
-            <a:pPr algn="l" marL="335280" indent="-335280">
+            <a:pPr marL="335280" indent="-335280" algn="l">
               <a:lnSpc>
                 <a:spcPct val="118000"/>
               </a:lnSpc>
@@ -6699,7 +6579,7 @@
           <a:bodyPr wrap="none" lIns="0" tIns="0" rIns="0" bIns="0" rtlCol="0" anchor="t"/>
           <a:lstStyle/>
           <a:p>
-            <a:pPr algn="l" indent="0" marL="0">
+            <a:pPr marL="0" indent="0" algn="l">
               <a:lnSpc>
                 <a:spcPct val="118000"/>
               </a:lnSpc>
@@ -6766,14 +6646,14 @@
           <a:bodyPr wrap="none" lIns="0" tIns="0" rIns="0" bIns="0" rtlCol="0" anchor="t"/>
           <a:lstStyle/>
           <a:p>
-            <a:pPr algn="l" indent="0" marL="0">
+            <a:pPr marL="0" indent="0" algn="l">
               <a:lnSpc>
                 <a:spcPct val="104000"/>
               </a:lnSpc>
               <a:buNone/>
             </a:pPr>
             <a:r>
-              <a:rPr lang="en-US" sz="1200" spc="72" kern="100" dirty="0">
+              <a:rPr lang="en-US" sz="1200" kern="100" spc="72" dirty="0">
                 <a:solidFill>
                   <a:srgbClr val="EB5324"/>
                 </a:solidFill>
@@ -6808,14 +6688,14 @@
           <a:bodyPr wrap="none" lIns="0" tIns="0" rIns="0" bIns="0" rtlCol="0" anchor="t"/>
           <a:lstStyle/>
           <a:p>
-            <a:pPr algn="l" indent="0" marL="0">
+            <a:pPr marL="0" indent="0" algn="l">
               <a:lnSpc>
                 <a:spcPct val="88000"/>
               </a:lnSpc>
               <a:buNone/>
             </a:pPr>
             <a:r>
-              <a:rPr lang="en-US" sz="3000" spc="-30" kern="100" dirty="0">
+              <a:rPr lang="en-US" sz="3000" kern="100" spc="-30" dirty="0">
                 <a:solidFill>
                   <a:srgbClr val="FFFFFF"/>
                 </a:solidFill>
@@ -6831,14 +6711,14 @@
       </p:sp>
       <p:pic>
         <p:nvPicPr>
-          <p:cNvPr id="4" name="Image 0" descr="preencoded.png">    </p:cNvPr>
+          <p:cNvPr id="4" name="Image 0" descr="preencoded.png"/>
           <p:cNvPicPr>
             <a:picLocks noChangeAspect="1"/>
           </p:cNvPicPr>
           <p:nvPr/>
         </p:nvPicPr>
         <p:blipFill>
-          <a:blip r:embed="rId1"/>
+          <a:blip r:embed="rId3"/>
           <a:stretch>
             <a:fillRect/>
           </a:stretch>
@@ -6876,8 +6756,20 @@
             <a:tbl>
               <a:tblPr/>
               <a:tblGrid>
-                <a:gridCol w="2394982"/>
-                <a:gridCol w="4649175"/>
+                <a:gridCol w="2394982">
+                  <a:extLst>
+                    <a:ext uri="{9D8B030D-6E8A-4147-A177-3AD203B41FA5}">
+                      <a16:colId xmlns:a16="http://schemas.microsoft.com/office/drawing/2014/main" val="20000"/>
+                    </a:ext>
+                  </a:extLst>
+                </a:gridCol>
+                <a:gridCol w="4649175">
+                  <a:extLst>
+                    <a:ext uri="{9D8B030D-6E8A-4147-A177-3AD203B41FA5}">
+                      <a16:colId xmlns:a16="http://schemas.microsoft.com/office/drawing/2014/main" val="20001"/>
+                    </a:ext>
+                  </a:extLst>
+                </a:gridCol>
               </a:tblGrid>
               <a:tr h="477726">
                 <a:tc>
@@ -6885,11 +6777,11 @@
                     <a:bodyPr/>
                     <a:lstStyle/>
                     <a:p>
-                      <a:pPr algn="l" indent="0" marL="0">
+                      <a:pPr marL="0" indent="0" algn="l">
                         <a:buNone/>
                       </a:pPr>
                       <a:r>
-                        <a:rPr lang="en-US" sz="1650" spc="99" kern="100" dirty="0">
+                        <a:rPr lang="en-US" sz="1650" kern="100" spc="99" dirty="0">
                           <a:solidFill>
                             <a:srgbClr val="FFFFFF"/>
                           </a:solidFill>
@@ -6950,11 +6842,11 @@
                     <a:bodyPr/>
                     <a:lstStyle/>
                     <a:p>
-                      <a:pPr algn="l" indent="0" marL="0">
+                      <a:pPr marL="0" indent="0" algn="l">
                         <a:buNone/>
                       </a:pPr>
                       <a:r>
-                        <a:rPr lang="en-US" sz="1650" spc="99" kern="100" dirty="0">
+                        <a:rPr lang="en-US" sz="1650" kern="100" spc="99" dirty="0">
                           <a:solidFill>
                             <a:srgbClr val="FFFFFF"/>
                           </a:solidFill>
@@ -7010,6 +6902,11 @@
                     </a:lnB>
                   </a:tcPr>
                 </a:tc>
+                <a:extLst>
+                  <a:ext uri="{0D108BD9-81ED-4DB2-BD59-A6C34878D82A}">
+                    <a16:rowId xmlns:a16="http://schemas.microsoft.com/office/drawing/2014/main" val="10000"/>
+                  </a:ext>
+                </a:extLst>
               </a:tr>
               <a:tr h="441612">
                 <a:tc>
@@ -7017,7 +6914,7 @@
                     <a:bodyPr/>
                     <a:lstStyle/>
                     <a:p>
-                      <a:pPr algn="l" indent="0" marL="0">
+                      <a:pPr marL="0" indent="0" algn="l">
                         <a:buNone/>
                       </a:pPr>
                       <a:r>
@@ -7082,7 +6979,7 @@
                     <a:bodyPr/>
                     <a:lstStyle/>
                     <a:p>
-                      <a:pPr algn="l" indent="0" marL="0">
+                      <a:pPr marL="0" indent="0" algn="l">
                         <a:buNone/>
                       </a:pPr>
                       <a:r>
@@ -7142,6 +7039,11 @@
                     </a:lnB>
                   </a:tcPr>
                 </a:tc>
+                <a:extLst>
+                  <a:ext uri="{0D108BD9-81ED-4DB2-BD59-A6C34878D82A}">
+                    <a16:rowId xmlns:a16="http://schemas.microsoft.com/office/drawing/2014/main" val="10001"/>
+                  </a:ext>
+                </a:extLst>
               </a:tr>
               <a:tr h="441612">
                 <a:tc>
@@ -7149,7 +7051,7 @@
                     <a:bodyPr/>
                     <a:lstStyle/>
                     <a:p>
-                      <a:pPr algn="l" indent="0" marL="0">
+                      <a:pPr marL="0" indent="0" algn="l">
                         <a:buNone/>
                       </a:pPr>
                       <a:r>
@@ -7214,7 +7116,7 @@
                     <a:bodyPr/>
                     <a:lstStyle/>
                     <a:p>
-                      <a:pPr algn="l" indent="0" marL="0">
+                      <a:pPr marL="0" indent="0" algn="l">
                         <a:buNone/>
                       </a:pPr>
                       <a:r>
@@ -7274,6 +7176,11 @@
                     </a:lnB>
                   </a:tcPr>
                 </a:tc>
+                <a:extLst>
+                  <a:ext uri="{0D108BD9-81ED-4DB2-BD59-A6C34878D82A}">
+                    <a16:rowId xmlns:a16="http://schemas.microsoft.com/office/drawing/2014/main" val="10002"/>
+                  </a:ext>
+                </a:extLst>
               </a:tr>
               <a:tr h="441612">
                 <a:tc>
@@ -7281,7 +7188,7 @@
                     <a:bodyPr/>
                     <a:lstStyle/>
                     <a:p>
-                      <a:pPr algn="l" indent="0" marL="0">
+                      <a:pPr marL="0" indent="0" algn="l">
                         <a:buNone/>
                       </a:pPr>
                       <a:r>
@@ -7346,7 +7253,7 @@
                     <a:bodyPr/>
                     <a:lstStyle/>
                     <a:p>
-                      <a:pPr algn="l" indent="0" marL="0">
+                      <a:pPr marL="0" indent="0" algn="l">
                         <a:buNone/>
                       </a:pPr>
                       <a:r>
@@ -7406,6 +7313,11 @@
                     </a:lnB>
                   </a:tcPr>
                 </a:tc>
+                <a:extLst>
+                  <a:ext uri="{0D108BD9-81ED-4DB2-BD59-A6C34878D82A}">
+                    <a16:rowId xmlns:a16="http://schemas.microsoft.com/office/drawing/2014/main" val="10003"/>
+                  </a:ext>
+                </a:extLst>
               </a:tr>
               <a:tr h="441612">
                 <a:tc>
@@ -7413,7 +7325,7 @@
                     <a:bodyPr/>
                     <a:lstStyle/>
                     <a:p>
-                      <a:pPr algn="l" indent="0" marL="0">
+                      <a:pPr marL="0" indent="0" algn="l">
                         <a:buNone/>
                       </a:pPr>
                       <a:r>
@@ -7478,7 +7390,7 @@
                     <a:bodyPr/>
                     <a:lstStyle/>
                     <a:p>
-                      <a:pPr algn="l" indent="0" marL="0">
+                      <a:pPr marL="0" indent="0" algn="l">
                         <a:buNone/>
                       </a:pPr>
                       <a:r>
@@ -7538,6 +7450,11 @@
                     </a:lnB>
                   </a:tcPr>
                 </a:tc>
+                <a:extLst>
+                  <a:ext uri="{0D108BD9-81ED-4DB2-BD59-A6C34878D82A}">
+                    <a16:rowId xmlns:a16="http://schemas.microsoft.com/office/drawing/2014/main" val="10004"/>
+                  </a:ext>
+                </a:extLst>
               </a:tr>
               <a:tr h="428912">
                 <a:tc>
@@ -7545,7 +7462,7 @@
                     <a:bodyPr/>
                     <a:lstStyle/>
                     <a:p>
-                      <a:pPr algn="l" indent="0" marL="0">
+                      <a:pPr marL="0" indent="0" algn="l">
                         <a:buNone/>
                       </a:pPr>
                       <a:r>
@@ -7610,7 +7527,7 @@
                     <a:bodyPr/>
                     <a:lstStyle/>
                     <a:p>
-                      <a:pPr algn="l" indent="0" marL="0">
+                      <a:pPr marL="0" indent="0" algn="l">
                         <a:buNone/>
                       </a:pPr>
                       <a:r>
@@ -7670,6 +7587,11 @@
                     </a:lnB>
                   </a:tcPr>
                 </a:tc>
+                <a:extLst>
+                  <a:ext uri="{0D108BD9-81ED-4DB2-BD59-A6C34878D82A}">
+                    <a16:rowId xmlns:a16="http://schemas.microsoft.com/office/drawing/2014/main" val="10005"/>
+                  </a:ext>
+                </a:extLst>
               </a:tr>
             </a:tbl>
           </a:graphicData>
@@ -7696,7 +7618,7 @@
           <a:bodyPr wrap="none" lIns="0" tIns="0" rIns="0" bIns="0" rtlCol="0" anchor="t"/>
           <a:lstStyle/>
           <a:p>
-            <a:pPr algn="l" indent="0" marL="0">
+            <a:pPr marL="0" indent="0" algn="l">
               <a:lnSpc>
                 <a:spcPct val="118000"/>
               </a:lnSpc>
@@ -7763,14 +7685,14 @@
           <a:bodyPr wrap="none" lIns="0" tIns="0" rIns="0" bIns="0" rtlCol="0" anchor="t"/>
           <a:lstStyle/>
           <a:p>
-            <a:pPr algn="l" indent="0" marL="0">
+            <a:pPr marL="0" indent="0" algn="l">
               <a:lnSpc>
                 <a:spcPct val="104000"/>
               </a:lnSpc>
               <a:buNone/>
             </a:pPr>
             <a:r>
-              <a:rPr lang="en-US" sz="1200" spc="72" kern="100" dirty="0">
+              <a:rPr lang="en-US" sz="1200" kern="100" spc="72" dirty="0">
                 <a:solidFill>
                   <a:srgbClr val="00978D"/>
                 </a:solidFill>
@@ -7807,14 +7729,14 @@
           </a:bodyPr>
           <a:lstStyle/>
           <a:p>
-            <a:pPr algn="l" indent="0" marL="0">
+            <a:pPr marL="0" indent="0" algn="l">
               <a:lnSpc>
                 <a:spcPct val="88000"/>
               </a:lnSpc>
               <a:buNone/>
             </a:pPr>
             <a:r>
-              <a:rPr lang="en-US" sz="3000" spc="-30" kern="100" dirty="0">
+              <a:rPr lang="en-US" sz="3000" kern="100" spc="-30" dirty="0">
                 <a:solidFill>
                   <a:srgbClr val="FFFFFF"/>
                 </a:solidFill>
@@ -7851,7 +7773,7 @@
           </a:bodyPr>
           <a:lstStyle/>
           <a:p>
-            <a:pPr algn="l" marL="335280" indent="-335280">
+            <a:pPr marL="335280" indent="-335280" algn="l">
               <a:lnSpc>
                 <a:spcPct val="118000"/>
               </a:lnSpc>
@@ -7872,7 +7794,7 @@
             <a:endParaRPr lang="en-US" sz="1650" dirty="0"/>
           </a:p>
           <a:p>
-            <a:pPr algn="l" marL="335280" indent="-335280">
+            <a:pPr marL="335280" indent="-335280" algn="l">
               <a:lnSpc>
                 <a:spcPct val="118000"/>
               </a:lnSpc>
@@ -7893,7 +7815,7 @@
             <a:endParaRPr lang="en-US" sz="1650" dirty="0"/>
           </a:p>
           <a:p>
-            <a:pPr algn="l" marL="335280" indent="-335280">
+            <a:pPr marL="335280" indent="-335280" algn="l">
               <a:lnSpc>
                 <a:spcPct val="118000"/>
               </a:lnSpc>
@@ -7914,7 +7836,7 @@
             <a:endParaRPr lang="en-US" sz="1650" dirty="0"/>
           </a:p>
           <a:p>
-            <a:pPr algn="l" marL="335280" indent="-335280">
+            <a:pPr marL="335280" indent="-335280" algn="l">
               <a:lnSpc>
                 <a:spcPct val="118000"/>
               </a:lnSpc>
@@ -7935,7 +7857,7 @@
             <a:endParaRPr lang="en-US" sz="1650" dirty="0"/>
           </a:p>
           <a:p>
-            <a:pPr algn="l" marL="335280" indent="-335280">
+            <a:pPr marL="335280" indent="-335280" algn="l">
               <a:lnSpc>
                 <a:spcPct val="118000"/>
               </a:lnSpc>
@@ -7980,7 +7902,7 @@
           </a:bodyPr>
           <a:lstStyle/>
           <a:p>
-            <a:pPr algn="l" indent="0" marL="0">
+            <a:pPr marL="0" indent="0" algn="l">
               <a:lnSpc>
                 <a:spcPct val="118000"/>
               </a:lnSpc>
@@ -8003,14 +7925,14 @@
       </p:sp>
       <p:pic>
         <p:nvPicPr>
-          <p:cNvPr id="6" name="Image 0" descr="preencoded.png">    </p:cNvPr>
+          <p:cNvPr id="6" name="Image 0" descr="preencoded.png"/>
           <p:cNvPicPr>
             <a:picLocks noChangeAspect="1"/>
           </p:cNvPicPr>
           <p:nvPr/>
         </p:nvPicPr>
         <p:blipFill>
-          <a:blip r:embed="rId1"/>
+          <a:blip r:embed="rId3"/>
           <a:stretch>
             <a:fillRect/>
           </a:stretch>
@@ -8326,4 +8248,299 @@
     </a:ext>
   </a:extLst>
 </a:theme>
+</file>
+
+<file path=ppt/theme/theme2.xml><?xml version="1.0" encoding="utf-8"?>
+<a:theme xmlns:a="http://schemas.openxmlformats.org/drawingml/2006/main" name="Office Teması">
+  <a:themeElements>
+    <a:clrScheme name="Office">
+      <a:dk1>
+        <a:sysClr val="windowText" lastClr="000000"/>
+      </a:dk1>
+      <a:lt1>
+        <a:sysClr val="window" lastClr="FFFFFF"/>
+      </a:lt1>
+      <a:dk2>
+        <a:srgbClr val="44546A"/>
+      </a:dk2>
+      <a:lt2>
+        <a:srgbClr val="E7E6E6"/>
+      </a:lt2>
+      <a:accent1>
+        <a:srgbClr val="4472C4"/>
+      </a:accent1>
+      <a:accent2>
+        <a:srgbClr val="ED7D31"/>
+      </a:accent2>
+      <a:accent3>
+        <a:srgbClr val="A5A5A5"/>
+      </a:accent3>
+      <a:accent4>
+        <a:srgbClr val="FFC000"/>
+      </a:accent4>
+      <a:accent5>
+        <a:srgbClr val="5B9BD5"/>
+      </a:accent5>
+      <a:accent6>
+        <a:srgbClr val="70AD47"/>
+      </a:accent6>
+      <a:hlink>
+        <a:srgbClr val="0563C1"/>
+      </a:hlink>
+      <a:folHlink>
+        <a:srgbClr val="954F72"/>
+      </a:folHlink>
+    </a:clrScheme>
+    <a:fontScheme name="Office">
+      <a:majorFont>
+        <a:latin typeface="Calibri Light" panose="020F0302020204030204"/>
+        <a:ea typeface=""/>
+        <a:cs typeface=""/>
+        <a:font script="Jpan" typeface="游ゴシック Light"/>
+        <a:font script="Hang" typeface="맑은 고딕"/>
+        <a:font script="Hans" typeface="等线 Light"/>
+        <a:font script="Hant" typeface="新細明體"/>
+        <a:font script="Arab" typeface="Times New Roman"/>
+        <a:font script="Hebr" typeface="Times New Roman"/>
+        <a:font script="Thai" typeface="Angsana New"/>
+        <a:font script="Ethi" typeface="Nyala"/>
+        <a:font script="Beng" typeface="Vrinda"/>
+        <a:font script="Gujr" typeface="Shruti"/>
+        <a:font script="Khmr" typeface="MoolBoran"/>
+        <a:font script="Knda" typeface="Tunga"/>
+        <a:font script="Guru" typeface="Raavi"/>
+        <a:font script="Cans" typeface="Euphemia"/>
+        <a:font script="Cher" typeface="Plantagenet Cherokee"/>
+        <a:font script="Yiii" typeface="Microsoft Yi Baiti"/>
+        <a:font script="Tibt" typeface="Microsoft Himalaya"/>
+        <a:font script="Thaa" typeface="MV Boli"/>
+        <a:font script="Deva" typeface="Mangal"/>
+        <a:font script="Telu" typeface="Gautami"/>
+        <a:font script="Taml" typeface="Latha"/>
+        <a:font script="Syrc" typeface="Estrangelo Edessa"/>
+        <a:font script="Orya" typeface="Kalinga"/>
+        <a:font script="Mlym" typeface="Kartika"/>
+        <a:font script="Laoo" typeface="DokChampa"/>
+        <a:font script="Sinh" typeface="Iskoola Pota"/>
+        <a:font script="Mong" typeface="Mongolian Baiti"/>
+        <a:font script="Viet" typeface="Times New Roman"/>
+        <a:font script="Uigh" typeface="Microsoft Uighur"/>
+        <a:font script="Geor" typeface="Sylfaen"/>
+        <a:font script="Armn" typeface="Arial"/>
+        <a:font script="Bugi" typeface="Leelawadee UI"/>
+        <a:font script="Bopo" typeface="Microsoft JhengHei"/>
+        <a:font script="Java" typeface="Javanese Text"/>
+        <a:font script="Lisu" typeface="Segoe UI"/>
+        <a:font script="Mymr" typeface="Myanmar Text"/>
+        <a:font script="Nkoo" typeface="Ebrima"/>
+        <a:font script="Olck" typeface="Nirmala UI"/>
+        <a:font script="Osma" typeface="Ebrima"/>
+        <a:font script="Phag" typeface="Phagspa"/>
+        <a:font script="Syrn" typeface="Estrangelo Edessa"/>
+        <a:font script="Syrj" typeface="Estrangelo Edessa"/>
+        <a:font script="Syre" typeface="Estrangelo Edessa"/>
+        <a:font script="Sora" typeface="Nirmala UI"/>
+        <a:font script="Tale" typeface="Microsoft Tai Le"/>
+        <a:font script="Talu" typeface="Microsoft New Tai Lue"/>
+        <a:font script="Tfng" typeface="Ebrima"/>
+      </a:majorFont>
+      <a:minorFont>
+        <a:latin typeface="Calibri" panose="020F0502020204030204"/>
+        <a:ea typeface=""/>
+        <a:cs typeface=""/>
+        <a:font script="Jpan" typeface="游ゴシック"/>
+        <a:font script="Hang" typeface="맑은 고딕"/>
+        <a:font script="Hans" typeface="等线"/>
+        <a:font script="Hant" typeface="新細明體"/>
+        <a:font script="Arab" typeface="Arial"/>
+        <a:font script="Hebr" typeface="Arial"/>
+        <a:font script="Thai" typeface="Cordia New"/>
+        <a:font script="Ethi" typeface="Nyala"/>
+        <a:font script="Beng" typeface="Vrinda"/>
+        <a:font script="Gujr" typeface="Shruti"/>
+        <a:font script="Khmr" typeface="DaunPenh"/>
+        <a:font script="Knda" typeface="Tunga"/>
+        <a:font script="Guru" typeface="Raavi"/>
+        <a:font script="Cans" typeface="Euphemia"/>
+        <a:font script="Cher" typeface="Plantagenet Cherokee"/>
+        <a:font script="Yiii" typeface="Microsoft Yi Baiti"/>
+        <a:font script="Tibt" typeface="Microsoft Himalaya"/>
+        <a:font script="Thaa" typeface="MV Boli"/>
+        <a:font script="Deva" typeface="Mangal"/>
+        <a:font script="Telu" typeface="Gautami"/>
+        <a:font script="Taml" typeface="Latha"/>
+        <a:font script="Syrc" typeface="Estrangelo Edessa"/>
+        <a:font script="Orya" typeface="Kalinga"/>
+        <a:font script="Mlym" typeface="Kartika"/>
+        <a:font script="Laoo" typeface="DokChampa"/>
+        <a:font script="Sinh" typeface="Iskoola Pota"/>
+        <a:font script="Mong" typeface="Mongolian Baiti"/>
+        <a:font script="Viet" typeface="Arial"/>
+        <a:font script="Uigh" typeface="Microsoft Uighur"/>
+        <a:font script="Geor" typeface="Sylfaen"/>
+        <a:font script="Armn" typeface="Arial"/>
+        <a:font script="Bugi" typeface="Leelawadee UI"/>
+        <a:font script="Bopo" typeface="Microsoft JhengHei"/>
+        <a:font script="Java" typeface="Javanese Text"/>
+        <a:font script="Lisu" typeface="Segoe UI"/>
+        <a:font script="Mymr" typeface="Myanmar Text"/>
+        <a:font script="Nkoo" typeface="Ebrima"/>
+        <a:font script="Olck" typeface="Nirmala UI"/>
+        <a:font script="Osma" typeface="Ebrima"/>
+        <a:font script="Phag" typeface="Phagspa"/>
+        <a:font script="Syrn" typeface="Estrangelo Edessa"/>
+        <a:font script="Syrj" typeface="Estrangelo Edessa"/>
+        <a:font script="Syre" typeface="Estrangelo Edessa"/>
+        <a:font script="Sora" typeface="Nirmala UI"/>
+        <a:font script="Tale" typeface="Microsoft Tai Le"/>
+        <a:font script="Talu" typeface="Microsoft New Tai Lue"/>
+        <a:font script="Tfng" typeface="Ebrima"/>
+      </a:minorFont>
+    </a:fontScheme>
+    <a:fmtScheme name="Office">
+      <a:fillStyleLst>
+        <a:solidFill>
+          <a:schemeClr val="phClr"/>
+        </a:solidFill>
+        <a:gradFill rotWithShape="1">
+          <a:gsLst>
+            <a:gs pos="0">
+              <a:schemeClr val="phClr">
+                <a:lumMod val="110000"/>
+                <a:satMod val="105000"/>
+                <a:tint val="67000"/>
+              </a:schemeClr>
+            </a:gs>
+            <a:gs pos="50000">
+              <a:schemeClr val="phClr">
+                <a:lumMod val="105000"/>
+                <a:satMod val="103000"/>
+                <a:tint val="73000"/>
+              </a:schemeClr>
+            </a:gs>
+            <a:gs pos="100000">
+              <a:schemeClr val="phClr">
+                <a:lumMod val="105000"/>
+                <a:satMod val="109000"/>
+                <a:tint val="81000"/>
+              </a:schemeClr>
+            </a:gs>
+          </a:gsLst>
+          <a:lin ang="5400000" scaled="0"/>
+        </a:gradFill>
+        <a:gradFill rotWithShape="1">
+          <a:gsLst>
+            <a:gs pos="0">
+              <a:schemeClr val="phClr">
+                <a:satMod val="103000"/>
+                <a:lumMod val="102000"/>
+                <a:tint val="94000"/>
+              </a:schemeClr>
+            </a:gs>
+            <a:gs pos="50000">
+              <a:schemeClr val="phClr">
+                <a:satMod val="110000"/>
+                <a:lumMod val="100000"/>
+                <a:shade val="100000"/>
+              </a:schemeClr>
+            </a:gs>
+            <a:gs pos="100000">
+              <a:schemeClr val="phClr">
+                <a:lumMod val="99000"/>
+                <a:satMod val="120000"/>
+                <a:shade val="78000"/>
+              </a:schemeClr>
+            </a:gs>
+          </a:gsLst>
+          <a:lin ang="5400000" scaled="0"/>
+        </a:gradFill>
+      </a:fillStyleLst>
+      <a:lnStyleLst>
+        <a:ln w="6350" cap="flat" cmpd="sng" algn="ctr">
+          <a:solidFill>
+            <a:schemeClr val="phClr"/>
+          </a:solidFill>
+          <a:prstDash val="solid"/>
+          <a:miter lim="800000"/>
+        </a:ln>
+        <a:ln w="12700" cap="flat" cmpd="sng" algn="ctr">
+          <a:solidFill>
+            <a:schemeClr val="phClr"/>
+          </a:solidFill>
+          <a:prstDash val="solid"/>
+          <a:miter lim="800000"/>
+        </a:ln>
+        <a:ln w="19050" cap="flat" cmpd="sng" algn="ctr">
+          <a:solidFill>
+            <a:schemeClr val="phClr"/>
+          </a:solidFill>
+          <a:prstDash val="solid"/>
+          <a:miter lim="800000"/>
+        </a:ln>
+      </a:lnStyleLst>
+      <a:effectStyleLst>
+        <a:effectStyle>
+          <a:effectLst/>
+        </a:effectStyle>
+        <a:effectStyle>
+          <a:effectLst/>
+        </a:effectStyle>
+        <a:effectStyle>
+          <a:effectLst>
+            <a:outerShdw blurRad="57150" dist="19050" dir="5400000" algn="ctr" rotWithShape="0">
+              <a:srgbClr val="000000">
+                <a:alpha val="63000"/>
+              </a:srgbClr>
+            </a:outerShdw>
+          </a:effectLst>
+        </a:effectStyle>
+      </a:effectStyleLst>
+      <a:bgFillStyleLst>
+        <a:solidFill>
+          <a:schemeClr val="phClr"/>
+        </a:solidFill>
+        <a:solidFill>
+          <a:schemeClr val="phClr">
+            <a:tint val="95000"/>
+            <a:satMod val="170000"/>
+          </a:schemeClr>
+        </a:solidFill>
+        <a:gradFill rotWithShape="1">
+          <a:gsLst>
+            <a:gs pos="0">
+              <a:schemeClr val="phClr">
+                <a:tint val="93000"/>
+                <a:satMod val="150000"/>
+                <a:shade val="98000"/>
+                <a:lumMod val="102000"/>
+              </a:schemeClr>
+            </a:gs>
+            <a:gs pos="50000">
+              <a:schemeClr val="phClr">
+                <a:tint val="98000"/>
+                <a:satMod val="130000"/>
+                <a:shade val="90000"/>
+                <a:lumMod val="103000"/>
+              </a:schemeClr>
+            </a:gs>
+            <a:gs pos="100000">
+              <a:schemeClr val="phClr">
+                <a:shade val="63000"/>
+                <a:satMod val="120000"/>
+              </a:schemeClr>
+            </a:gs>
+          </a:gsLst>
+          <a:lin ang="5400000" scaled="0"/>
+        </a:gradFill>
+      </a:bgFillStyleLst>
+    </a:fmtScheme>
+  </a:themeElements>
+  <a:objectDefaults/>
+  <a:extraClrSchemeLst/>
+  <a:extLst>
+    <a:ext uri="{05A4C25C-085E-4340-85A3-A5531E510DB2}">
+      <thm15:themeFamily xmlns:thm15="http://schemas.microsoft.com/office/thememl/2012/main" name="Office Theme" id="{62F939B6-93AF-4DB8-9C6B-D6C7DFDC589F}" vid="{4A3C46E8-61CC-4603-A589-7422A47A8E4A}"/>
+    </a:ext>
+  </a:extLst>
+</a:theme>
 </file>
</xml_diff>